<commit_message>
Talk slide 12: the gauge check now shows the steady 40-64 cm SWOT-gauge gap (PASS)
</commit_message>
<xml_diff>
--- a/docs/presentation/swot-tank-tracker-proposal-talk.pptx
+++ b/docs/presentation/swot-tank-tracker-proposal-talk.pptx
@@ -127,7 +127,7 @@
   <p:extLst>
     <p:ext uri="{521415D9-36F7-43E2-AB2F-B90AF26B5E84}">
       <p14:sectionLst xmlns:p14="http://schemas.microsoft.com/office/powerpoint/2010/main">
-        <p14:section name="Introduction" id="{d3605d1b-6cc7-3352-2757-96b96fbdf329}">
+        <p14:section name="Introduction" id="{ed9a8fe9-e224-9b85-40f8-96ef9062238c}">
           <p14:sldIdLst>
             <p14:sldId id="256"/>
             <p14:sldId id="257"/>
@@ -135,28 +135,28 @@
             <p14:sldId id="259"/>
           </p14:sldIdLst>
         </p14:section>
-        <p14:section name="The satellites" id="{2445117b-27b7-f343-e1ce-e7be7c6c3492}">
+        <p14:section name="The satellites" id="{4d13fd84-041a-c254-022a-0b49baecfc39}">
           <p14:sldIdLst>
             <p14:sldId id="260"/>
             <p14:sldId id="261"/>
             <p14:sldId id="262"/>
           </p14:sldIdLst>
         </p14:section>
-        <p14:section name="Study and method" id="{d230cae1-07ac-4212-00c2-62f4f984c7b6}">
+        <p14:section name="Study and method" id="{e4177b84-bdb1-1dc9-28d8-c92839935fc2}">
           <p14:sldIdLst>
             <p14:sldId id="263"/>
             <p14:sldId id="264"/>
             <p14:sldId id="265"/>
           </p14:sldIdLst>
         </p14:section>
-        <p14:section name="Evidence" id="{a57bcab5-90d9-1b15-c400-5b9c9bdf4bad}">
+        <p14:section name="Evidence" id="{e3c2900f-7c6c-2f20-251c-76143f2cb1f3}">
           <p14:sldIdLst>
             <p14:sldId id="266"/>
             <p14:sldId id="267"/>
             <p14:sldId id="268"/>
           </p14:sldIdLst>
         </p14:section>
-        <p14:section name="Plan" id="{2bf72b58-6f17-d8e9-9ea9-9c52d53ddaf4}">
+        <p14:section name="Plan" id="{89120a4b-27a5-79c2-572e-0b3307ff8cb7}">
           <p14:sldIdLst>
             <p14:sldId id="269"/>
             <p14:sldId id="270"/>
@@ -6414,7 +6414,7 @@
                 <a:ea typeface="+mj-lt" pitchFamily="34" charset="-122"/>
                 <a:cs typeface="+mj-lt" pitchFamily="34" charset="-120"/>
               </a:rPr>
-              <a:t>~1 m</a:t>
+              <a:t>40–64 cm</a:t>
             </a:r>
             <a:endParaRPr lang="en-US" sz="3000" dirty="0"/>
           </a:p>
@@ -6450,7 +6450,7 @@
                   <a:schemeClr val="tx1"/>
                 </a:solidFill>
               </a:rPr>
-              <a:t>difference between SWOT and gauges on 4 reservoirs, with readings 13 to 20 days apart</a:t>
+              <a:t>a steady gap between SWOT and the gauges at all 5 reservoirs; one fixed correction each</a:t>
             </a:r>
             <a:endParaRPr lang="en-US" sz="1250" dirty="0"/>
           </a:p>
@@ -6458,7 +6458,7 @@
       </p:sp>
       <p:sp>
         <p:nvSpPr>
-          <p:cNvPr id="22" name="status OK"/>
+          <p:cNvPr id="22" name="status PASS"/>
           <p:cNvSpPr/>
           <p:nvPr/>
         </p:nvSpPr>
@@ -6537,7 +6537,7 @@
                   <a:schemeClr val="bg1"/>
                 </a:solidFill>
               </a:rPr>
-              <a:t>OK</a:t>
+              <a:t>PASS</a:t>
             </a:r>
             <a:endParaRPr lang="en-US" sz="1150" dirty="0"/>
           </a:p>

</xml_diff>

<commit_message>
Give each member a model to train: B a SWOT trust model, C a storage forecast
B trains gradient boosting that learns how wrong each SWOT reading is (RQ2). C trains an LSTM that forecasts storage 2-4 weeks ahead; RQ4 is now core, not a stretch goal. Both use the Irrigation Department's daily storage for 117 reservoirs.
</commit_message>
<xml_diff>
--- a/docs/presentation/swot-tank-tracker-proposal-talk.pptx
+++ b/docs/presentation/swot-tank-tracker-proposal-talk.pptx
@@ -127,7 +127,7 @@
   <p:extLst>
     <p:ext uri="{521415D9-36F7-43E2-AB2F-B90AF26B5E84}">
       <p14:sectionLst xmlns:p14="http://schemas.microsoft.com/office/powerpoint/2010/main">
-        <p14:section name="Introduction" id="{ed9a8fe9-e224-9b85-40f8-96ef9062238c}">
+        <p14:section name="Introduction" id="{58285f1d-be3d-a84f-afed-f8c45c056ebf}">
           <p14:sldIdLst>
             <p14:sldId id="256"/>
             <p14:sldId id="257"/>
@@ -135,28 +135,28 @@
             <p14:sldId id="259"/>
           </p14:sldIdLst>
         </p14:section>
-        <p14:section name="The satellites" id="{4d13fd84-041a-c254-022a-0b49baecfc39}">
+        <p14:section name="The satellites" id="{36f4b2e8-185e-836f-ec15-7966a2d9b702}">
           <p14:sldIdLst>
             <p14:sldId id="260"/>
             <p14:sldId id="261"/>
             <p14:sldId id="262"/>
           </p14:sldIdLst>
         </p14:section>
-        <p14:section name="Study and method" id="{e4177b84-bdb1-1dc9-28d8-c92839935fc2}">
+        <p14:section name="Study and method" id="{605ca566-8139-aeb0-cd9a-e187ddfe1808}">
           <p14:sldIdLst>
             <p14:sldId id="263"/>
             <p14:sldId id="264"/>
             <p14:sldId id="265"/>
           </p14:sldIdLst>
         </p14:section>
-        <p14:section name="Evidence" id="{e3c2900f-7c6c-2f20-251c-76143f2cb1f3}">
+        <p14:section name="Evidence" id="{43a5f231-0145-a545-a9d9-e158ade9b0b2}">
           <p14:sldIdLst>
             <p14:sldId id="266"/>
             <p14:sldId id="267"/>
             <p14:sldId id="268"/>
           </p14:sldIdLst>
         </p14:section>
-        <p14:section name="Plan" id="{89120a4b-27a5-79c2-572e-0b3307ff8cb7}">
+        <p14:section name="Plan" id="{a4f3036b-b7c9-19e6-eefd-33bf7911b125}">
           <p14:sldIdLst>
             <p14:sldId id="269"/>
             <p14:sldId id="270"/>
@@ -8094,7 +8094,7 @@
                   <a:schemeClr val="tx1"/>
                 </a:solidFill>
               </a:rPr>
-              <a:t>How accurate is SWOT on reservoirs and on small village tanks, and can its "suspect" readings be trusted?</a:t>
+              <a:t>How accurate is SWOT on reservoirs and village tanks, and can a learned model tell which readings to trust better than SWOT's own flags?</a:t>
             </a:r>
             <a:endParaRPr lang="en-US" sz="1600" dirty="0"/>
           </a:p>
@@ -8130,7 +8130,7 @@
                   <a:schemeClr val="accent6"/>
                 </a:solidFill>
               </a:rPr>
-              <a:t>Measured by error in cm against gauge readings</a:t>
+              <a:t>Measured by error in cm against gauges, on reservoirs the model never saw</a:t>
             </a:r>
             <a:endParaRPr lang="en-US" sz="1150" dirty="0"/>
           </a:p>
@@ -8316,13 +8316,13 @@
             </a:avLst>
           </a:prstGeom>
           <a:solidFill>
-            <a:schemeClr val="bg1"/>
+            <a:schemeClr val="bg2"/>
           </a:solidFill>
-          <a:ln w="15875">
+          <a:ln w="9525">
             <a:solidFill>
-              <a:srgbClr val="D5DDE3"/>
+              <a:schemeClr val="bg2"/>
             </a:solidFill>
-            <a:prstDash val="dash"/>
+            <a:prstDash val="solid"/>
           </a:ln>
         </p:spPr>
       </p:sp>
@@ -8341,11 +8341,11 @@
             <a:avLst/>
           </a:prstGeom>
           <a:solidFill>
-            <a:schemeClr val="accent6"/>
+            <a:schemeClr val="accent1"/>
           </a:solidFill>
           <a:ln w="12700">
             <a:solidFill>
-              <a:schemeClr val="accent6"/>
+              <a:schemeClr val="accent1"/>
             </a:solidFill>
             <a:prstDash val="solid"/>
           </a:ln>
@@ -8420,7 +8420,7 @@
                   <a:schemeClr val="tx1"/>
                 </a:solidFill>
               </a:rPr>
-              <a:t>Can storage be forecast 2–4 weeks ahead from recent storage and rainfall?</a:t>
+              <a:t>Can a deep-learning model forecast each tank's storage 2–4 weeks ahead better than a "no change" forecast?</a:t>
             </a:r>
             <a:endParaRPr lang="en-US" sz="1600" dirty="0"/>
           </a:p>
@@ -8456,7 +8456,7 @@
                   <a:schemeClr val="accent6"/>
                 </a:solidFill>
               </a:rPr>
-              <a:t>Stretch goal, compared with a "no change" forecast</a:t>
+              <a:t>Measured by error as a % of capacity at 1, 2 and 4 weeks</a:t>
             </a:r>
             <a:endParaRPr lang="en-US" sz="1150" dirty="0"/>
           </a:p>
@@ -8564,7 +8564,7 @@
                   <a:schemeClr val="tx1"/>
                 </a:solidFill>
               </a:rPr>
-              <a:t>Who does what: one research question each</a:t>
+              <a:t>Who does what: one model each</a:t>
             </a:r>
             <a:endParaRPr lang="en-US" sz="3400" dirty="0"/>
           </a:p>
@@ -8600,7 +8600,7 @@
                   <a:schemeClr val="accent6"/>
                 </a:solidFill>
               </a:rPr>
-              <a:t>Each of us owns one core research question from start to finish.</a:t>
+              <a:t>Each of us owns a research question from start to finish, and trains one model for it.</a:t>
             </a:r>
             <a:endParaRPr lang="en-US" sz="1400" dirty="0"/>
           </a:p>
@@ -8879,7 +8879,7 @@
                   <a:schemeClr val="tx1"/>
                 </a:solidFill>
               </a:rPr>
-              <a:t>Sentinel-1 and Sentinel-2 deep-learning model</a:t>
+              <a:t>A water-plant class for covered tanks</a:t>
             </a:r>
             <a:endParaRPr lang="en-US" sz="1400" dirty="0"/>
           </a:p>
@@ -8897,7 +8897,7 @@
                   <a:schemeClr val="tx1"/>
                 </a:solidFill>
               </a:rPr>
-              <a:t>A water-plant class for covered tanks</a:t>
+              <a:t>Model: a Sentinel-1 and Sentinel-2 water map (U-Net)</a:t>
             </a:r>
             <a:endParaRPr lang="en-US" sz="1400" dirty="0"/>
           </a:p>
@@ -9228,7 +9228,7 @@
                   <a:schemeClr val="tx1"/>
                 </a:solidFill>
               </a:rPr>
-              <a:t>SWOT heights from Hydrocron, poor readings removed</a:t>
+              <a:t>SWOT heights from Hydrocron, checked against gauges</a:t>
             </a:r>
             <a:endParaRPr lang="en-US" sz="1400" dirty="0"/>
           </a:p>
@@ -9246,7 +9246,7 @@
                   <a:schemeClr val="tx1"/>
                 </a:solidFill>
               </a:rPr>
-              <a:t>Gauge data: daily records, history and field photos</a:t>
+              <a:t>Gauge data: daily records and history</a:t>
             </a:r>
             <a:endParaRPr lang="en-US" sz="1400" dirty="0"/>
           </a:p>
@@ -9264,7 +9264,7 @@
                   <a:schemeClr val="tx1"/>
                 </a:solidFill>
               </a:rPr>
-              <a:t>Tests whether "suspect" readings can be trusted</a:t>
+              <a:t>Model: a SWOT trust model (gradient boosting)</a:t>
             </a:r>
             <a:endParaRPr lang="en-US" sz="1400" dirty="0"/>
           </a:p>
@@ -9334,7 +9334,7 @@
                   <a:schemeClr val="tx1"/>
                 </a:solidFill>
               </a:rPr>
-              <a:t>SWOT accuracy report</a:t>
+              <a:t>accuracy report and trust model</a:t>
             </a:r>
             <a:endParaRPr lang="en-US" sz="1250" dirty="0"/>
           </a:p>
@@ -9492,7 +9492,7 @@
                 <a:ea typeface="+mj-lt" pitchFamily="34" charset="-122"/>
                 <a:cs typeface="+mj-lt" pitchFamily="34" charset="-120"/>
               </a:rPr>
-              <a:t>Storage and dashboard</a:t>
+              <a:t>Storage and forecast</a:t>
             </a:r>
             <a:endParaRPr lang="en-US" sz="1900" dirty="0"/>
           </a:p>
@@ -9563,14 +9563,14 @@
       </p:sp>
       <p:sp>
         <p:nvSpPr>
-          <p:cNvPr id="31" name="RQ4 stretch"/>
+          <p:cNvPr id="31" name="RQ4"/>
           <p:cNvSpPr/>
           <p:nvPr/>
         </p:nvSpPr>
         <p:spPr>
           <a:xfrm>
             <a:off x="9121445" y="2926080"/>
-            <a:ext cx="1188720" cy="310896"/>
+            <a:ext cx="640080" cy="310896"/>
           </a:xfrm>
           <a:prstGeom prst="roundRect">
             <a:avLst>
@@ -9578,13 +9578,13 @@
             </a:avLst>
           </a:prstGeom>
           <a:solidFill>
-            <a:schemeClr val="bg1"/>
+            <a:schemeClr val="accent2"/>
           </a:solidFill>
           <a:ln w="12700">
             <a:solidFill>
-              <a:schemeClr val="accent6"/>
+              <a:schemeClr val="accent2"/>
             </a:solidFill>
-            <a:prstDash val="dash"/>
+            <a:prstDash val="solid"/>
           </a:ln>
         </p:spPr>
       </p:sp>
@@ -9597,7 +9597,7 @@
         <p:spPr>
           <a:xfrm>
             <a:off x="9121445" y="2926080"/>
-            <a:ext cx="1188720" cy="310896"/>
+            <a:ext cx="640080" cy="310896"/>
           </a:xfrm>
           <a:prstGeom prst="rect">
             <a:avLst/>
@@ -9615,10 +9615,10 @@
             <a:r>
               <a:rPr lang="en-US" sz="1200" b="1" dirty="0">
                 <a:solidFill>
-                  <a:schemeClr val="accent6"/>
-                </a:solidFill>
-              </a:rPr>
-              <a:t>RQ4 stretch</a:t>
+                  <a:schemeClr val="bg1"/>
+                </a:solidFill>
+              </a:rPr>
+              <a:t>RQ4</a:t>
             </a:r>
             <a:endParaRPr lang="en-US" sz="1200" dirty="0"/>
           </a:p>
@@ -9694,7 +9694,7 @@
                   <a:schemeClr val="tx1"/>
                 </a:solidFill>
               </a:rPr>
-              <a:t>Dashboard, and the forecast if time allows</a:t>
+              <a:t>Model: a 2–4 week storage forecast (LSTM)</a:t>
             </a:r>
             <a:endParaRPr lang="en-US" sz="1400" dirty="0"/>
           </a:p>
@@ -9764,7 +9764,7 @@
                   <a:schemeClr val="tx1"/>
                 </a:solidFill>
               </a:rPr>
-              <a:t>storage series and dashboard</a:t>
+              <a:t>storage, forecast and dashboard</a:t>
             </a:r>
             <a:endParaRPr lang="en-US" sz="1250" dirty="0"/>
           </a:p>
@@ -10831,7 +10831,7 @@
                   <a:schemeClr val="accent6"/>
                 </a:solidFill>
               </a:rPr>
-              <a:t>How accurate is SWOT on reservoirs and on small village tanks, and can its "suspect" readings be trusted?</a:t>
+              <a:t>How accurate is SWOT on reservoirs and village tanks, and can a learned model tell which readings to trust better than SWOT's own flags?</a:t>
             </a:r>
             <a:endParaRPr lang="en-US" sz="1400" dirty="0"/>
           </a:p>
@@ -11004,7 +11004,7 @@
                   <a:schemeClr val="tx1"/>
                 </a:solidFill>
               </a:rPr>
-              <a:t>"Good" against "suspect" readings: how much extra error?</a:t>
+              <a:t>Labels for the model: each reading's error at the 117 department reservoirs</a:t>
             </a:r>
             <a:endParaRPr lang="en-US" sz="1500" dirty="0"/>
           </a:p>
@@ -11022,7 +11022,7 @@
                   <a:schemeClr val="tx1"/>
                 </a:solidFill>
               </a:rPr>
-              <a:t>Effect of lake size, distance from the track and season</a:t>
+              <a:t>The trust model against SWOT's own flags, on reservoirs it never saw</a:t>
             </a:r>
             <a:endParaRPr lang="en-US" sz="1500" dirty="0"/>
           </a:p>
@@ -11202,7 +11202,7 @@
                   <a:schemeClr val="tx1"/>
                 </a:solidFill>
               </a:rPr>
-              <a:t>Hydrocron pipeline: each tank's lake ID, every pass, cleaned with quality flags and an outlier test</a:t>
+              <a:t>Hydrocron pipeline: each tank's lake ID, every pass</a:t>
             </a:r>
             <a:endParaRPr lang="en-US" sz="1500" dirty="0"/>
           </a:p>
@@ -11220,7 +11220,7 @@
                   <a:schemeClr val="tx1"/>
                 </a:solidFill>
               </a:rPr>
-              <a:t>Gauge zero in metres above sea level: full supply level minus full supply depth</a:t>
+              <a:t>Trust model: gradient boosting (XGBoost or LightGBM) on SWOT's quality fields, track distance, lake size and season</a:t>
             </a:r>
             <a:endParaRPr lang="en-US" sz="1500" dirty="0"/>
           </a:p>
@@ -11238,7 +11238,7 @@
                   <a:schemeClr val="tx1"/>
                 </a:solidFill>
               </a:rPr>
-              <a:t>Daily logger for the department's sheet; storage history turned back into gauge heights</a:t>
+              <a:t>Gauge zero in metres above sea level: full supply level minus full supply depth</a:t>
             </a:r>
             <a:endParaRPr lang="en-US" sz="1500" dirty="0"/>
           </a:p>
@@ -11256,7 +11256,7 @@
                   <a:schemeClr val="tx1"/>
                 </a:solidFill>
               </a:rPr>
-              <a:t>Field visits on pass days: photos of the gauge</a:t>
+              <a:t>Daily logger for the department's sheet; storage history turned back into gauge heights</a:t>
             </a:r>
             <a:endParaRPr lang="en-US" sz="1500" dirty="0"/>
           </a:p>
@@ -11379,7 +11379,7 @@
                   <a:schemeClr val="bg1"/>
                 </a:solidFill>
               </a:rPr>
-              <a:t>SWOT accuracy report, and the fixed gap for each reservoir</a:t>
+              <a:t>SWOT accuracy report, the fixed gap for each reservoir, and a trust model that scores every reading</a:t>
             </a:r>
             <a:endParaRPr lang="en-US" sz="1500" dirty="0"/>
           </a:p>
@@ -11487,7 +11487,7 @@
                   <a:schemeClr val="tx1"/>
                 </a:solidFill>
               </a:rPr>
-              <a:t>Member C: Storage and dashboard</a:t>
+              <a:t>Member C: Storage and forecast</a:t>
             </a:r>
             <a:endParaRPr lang="en-US" sz="3400" dirty="0"/>
           </a:p>
@@ -11558,14 +11558,14 @@
       </p:sp>
       <p:sp>
         <p:nvSpPr>
-          <p:cNvPr id="5" name="RQ4 stretch"/>
+          <p:cNvPr id="5" name="RQ4"/>
           <p:cNvSpPr/>
           <p:nvPr/>
         </p:nvSpPr>
         <p:spPr>
           <a:xfrm>
             <a:off x="1298448" y="1207008"/>
-            <a:ext cx="1188720" cy="310896"/>
+            <a:ext cx="640080" cy="310896"/>
           </a:xfrm>
           <a:prstGeom prst="roundRect">
             <a:avLst>
@@ -11573,13 +11573,13 @@
             </a:avLst>
           </a:prstGeom>
           <a:solidFill>
-            <a:schemeClr val="bg1"/>
+            <a:schemeClr val="accent2"/>
           </a:solidFill>
           <a:ln w="12700">
             <a:solidFill>
-              <a:schemeClr val="accent6"/>
+              <a:schemeClr val="accent2"/>
             </a:solidFill>
-            <a:prstDash val="dash"/>
+            <a:prstDash val="solid"/>
           </a:ln>
         </p:spPr>
       </p:sp>
@@ -11592,7 +11592,7 @@
         <p:spPr>
           <a:xfrm>
             <a:off x="1298448" y="1207008"/>
-            <a:ext cx="1188720" cy="310896"/>
+            <a:ext cx="640080" cy="310896"/>
           </a:xfrm>
           <a:prstGeom prst="rect">
             <a:avLst/>
@@ -11610,46 +11610,46 @@
             <a:r>
               <a:rPr lang="en-US" sz="1200" b="1" dirty="0">
                 <a:solidFill>
+                  <a:schemeClr val="bg1"/>
+                </a:solidFill>
+              </a:rPr>
+              <a:t>RQ4</a:t>
+            </a:r>
+            <a:endParaRPr lang="en-US" sz="1200" dirty="0"/>
+          </a:p>
+        </p:txBody>
+      </p:sp>
+      <p:sp>
+        <p:nvSpPr>
+          <p:cNvPr id="7" name="Text 5"/>
+          <p:cNvSpPr txBox="1"/>
+          <p:nvPr/>
+        </p:nvSpPr>
+        <p:spPr>
+          <a:xfrm>
+            <a:off x="2139696" y="1161288"/>
+            <a:ext cx="9503359" cy="411480"/>
+          </a:xfrm>
+          <a:prstGeom prst="rect">
+            <a:avLst/>
+          </a:prstGeom>
+          <a:noFill/>
+          <a:ln/>
+        </p:spPr>
+        <p:txBody>
+          <a:bodyPr wrap="square" lIns="0" tIns="0" rIns="0" bIns="0" rtlCol="0" anchor="ctr"/>
+          <a:lstStyle/>
+          <a:p>
+            <a:pPr indent="0" marL="0">
+              <a:buNone/>
+            </a:pPr>
+            <a:r>
+              <a:rPr lang="en-US" sz="1400" dirty="0">
+                <a:solidFill>
                   <a:schemeClr val="accent6"/>
                 </a:solidFill>
               </a:rPr>
-              <a:t>RQ4 stretch</a:t>
-            </a:r>
-            <a:endParaRPr lang="en-US" sz="1200" dirty="0"/>
-          </a:p>
-        </p:txBody>
-      </p:sp>
-      <p:sp>
-        <p:nvSpPr>
-          <p:cNvPr id="7" name="Text 5"/>
-          <p:cNvSpPr txBox="1"/>
-          <p:nvPr/>
-        </p:nvSpPr>
-        <p:spPr>
-          <a:xfrm>
-            <a:off x="2688336" y="1161288"/>
-            <a:ext cx="8954719" cy="411480"/>
-          </a:xfrm>
-          <a:prstGeom prst="rect">
-            <a:avLst/>
-          </a:prstGeom>
-          <a:noFill/>
-          <a:ln/>
-        </p:spPr>
-        <p:txBody>
-          <a:bodyPr wrap="square" lIns="0" tIns="0" rIns="0" bIns="0" rtlCol="0" anchor="ctr"/>
-          <a:lstStyle/>
-          <a:p>
-            <a:pPr indent="0" marL="0">
-              <a:buNone/>
-            </a:pPr>
-            <a:r>
-              <a:rPr lang="en-US" sz="1400" dirty="0">
-                <a:solidFill>
-                  <a:schemeClr val="accent6"/>
-                </a:solidFill>
-              </a:rPr>
-              <a:t>Does AI water area plus SWOT height give storage close to official and measured values?</a:t>
+              <a:t>Does AI water area plus SWOT height give storage close to official values, and can a deep-learning model forecast it 2–4 weeks ahead?</a:t>
             </a:r>
             <a:endParaRPr lang="en-US" sz="1400" dirty="0"/>
           </a:p>
@@ -11858,25 +11858,7 @@
                   <a:schemeClr val="tx1"/>
                 </a:solidFill>
               </a:rPr>
-              <a:t>Error budget: height error plus area error, layer by layer</a:t>
-            </a:r>
-            <a:endParaRPr lang="en-US" sz="1500" dirty="0"/>
-          </a:p>
-          <a:p>
-            <a:pPr marL="342900" indent="-342900">
-              <a:spcAft>
-                <a:spcPts val="800"/>
-              </a:spcAft>
-              <a:buSzPct val="100000"/>
-              <a:buChar char="•"/>
-            </a:pPr>
-            <a:r>
-              <a:rPr lang="en-US" sz="1500" dirty="0">
-                <a:solidFill>
-                  <a:schemeClr val="tx1"/>
-                </a:solidFill>
-              </a:rPr>
-              <a:t>RQ4: 2–4 week forecast against a "no change" forecast</a:t>
+              <a:t>Forecast error at 1, 2 and 4 weeks, against "no change" and the seasonal average</a:t>
             </a:r>
             <a:endParaRPr lang="en-US" sz="1500" dirty="0"/>
           </a:p>
@@ -12056,7 +12038,7 @@
                   <a:schemeClr val="tx1"/>
                 </a:solidFill>
               </a:rPr>
-              <a:t>Dashboard: storage and safe limits for each tank</a:t>
+              <a:t>Forecast model: an LSTM with a gradient-boosting baseline, trained on 117 reservoirs' daily storage (2020–2026), rain and evaporation</a:t>
             </a:r>
             <a:endParaRPr lang="en-US" sz="1500" dirty="0"/>
           </a:p>
@@ -12074,7 +12056,7 @@
                   <a:schemeClr val="tx1"/>
                 </a:solidFill>
               </a:rPr>
-              <a:t>Automatic updates with GitHub Actions</a:t>
+              <a:t>Dashboard: storage, safe limits and the forecast for each tank</a:t>
             </a:r>
             <a:endParaRPr lang="en-US" sz="1500" dirty="0"/>
           </a:p>
@@ -12092,7 +12074,7 @@
                   <a:schemeClr val="tx1"/>
                 </a:solidFill>
               </a:rPr>
-              <a:t>Forecast model with rain and evaporation, if time allows</a:t>
+              <a:t>Automatic updates with GitHub Actions</a:t>
             </a:r>
             <a:endParaRPr lang="en-US" sz="1500" dirty="0"/>
           </a:p>
@@ -12215,7 +12197,7 @@
                   <a:schemeClr val="bg1"/>
                 </a:solidFill>
               </a:rPr>
-              <a:t>storage for every tank with safe limits, on a dashboard</a:t>
+              <a:t>storage for every tank with safe limits, and a 2–4 week forecast, on a dashboard</a:t>
             </a:r>
             <a:endParaRPr lang="en-US" sz="1500" dirty="0"/>
           </a:p>
@@ -12331,7 +12313,7 @@
       </p:sp>
       <p:sp>
         <p:nvSpPr>
-          <p:cNvPr id="3" name="icon FaDatabase"/>
+          <p:cNvPr id="3" name="icon FaBrain"/>
           <p:cNvSpPr/>
           <p:nvPr/>
         </p:nvSpPr>
@@ -12408,7 +12390,7 @@
                   <a:schemeClr val="tx1"/>
                 </a:solidFill>
               </a:rPr>
-              <a:t>A labelled dataset of Sri Lankan tank water masks</a:t>
+              <a:t>A labelled dataset and an AI water map that works under cloud and water plants</a:t>
             </a:r>
             <a:endParaRPr lang="en-US" sz="1600" dirty="0"/>
           </a:p>
@@ -12416,7 +12398,7 @@
       </p:sp>
       <p:sp>
         <p:nvSpPr>
-          <p:cNvPr id="6" name="icon FaBrain"/>
+          <p:cNvPr id="6" name="icon FaSatellite"/>
           <p:cNvSpPr/>
           <p:nvPr/>
         </p:nvSpPr>
@@ -12493,7 +12475,7 @@
                   <a:schemeClr val="tx1"/>
                 </a:solidFill>
               </a:rPr>
-              <a:t>An AI water map that works under cloud and water plants</a:t>
+              <a:t>A SWOT trust model that scores every reading</a:t>
             </a:r>
             <a:endParaRPr lang="en-US" sz="1600" dirty="0"/>
           </a:p>
@@ -12578,7 +12560,7 @@
                   <a:schemeClr val="tx1"/>
                 </a:solidFill>
               </a:rPr>
-              <a:t>Height–area–volume curves for all 13 tanks</a:t>
+              <a:t>Curves and storage every 5–12 days for all 13 tanks</a:t>
             </a:r>
             <a:endParaRPr lang="en-US" sz="1600" dirty="0"/>
           </a:p>
@@ -12663,7 +12645,7 @@
                   <a:schemeClr val="tx1"/>
                 </a:solidFill>
               </a:rPr>
-              <a:t>Storage every 5–12 days, shown on a dashboard</a:t>
+              <a:t>A 2–4 week storage forecast, shown on a dashboard</a:t>
             </a:r>
             <a:endParaRPr lang="en-US" sz="1600" dirty="0"/>
           </a:p>
@@ -13098,7 +13080,7 @@
                   <a:schemeClr val="accent6"/>
                 </a:solidFill>
               </a:rPr>
-              <a:t>Labelled data, gauge readings, AI water model and SWOT curves</a:t>
+              <a:t>Labelled data, gauge readings, and the three models: water map, trust model, forecast</a:t>
             </a:r>
             <a:endParaRPr lang="en-US" sz="1250" dirty="0"/>
           </a:p>

</xml_diff>

<commit_message>
New plan for Members B and C: B turns SWOT height and water area into % full, C forecasts and runs the system
B (RQ2 and RQ3): SWOT accuracy, a trust screen that cleans every reading, and a
gradient-boosting storage model trained on about 100 gauged reservoirs, tested on
reservoirs it never saw. C (RQ4): the LSTM forecast, the chain after every pass and
the dashboard. Proposal PDF, talk (no speaker notes) and the plan table updated.
</commit_message>
<xml_diff>
--- a/docs/presentation/swot-tank-tracker-proposal-talk.pptx
+++ b/docs/presentation/swot-tank-tracker-proposal-talk.pptx
@@ -127,7 +127,7 @@
   <p:extLst>
     <p:ext uri="{521415D9-36F7-43E2-AB2F-B90AF26B5E84}">
       <p14:sectionLst xmlns:p14="http://schemas.microsoft.com/office/powerpoint/2010/main">
-        <p14:section name="Introduction" id="{58285f1d-be3d-a84f-afed-f8c45c056ebf}">
+        <p14:section name="Introduction" id="{3f6419a0-d7b3-caf8-cefb-36542fd2a945}">
           <p14:sldIdLst>
             <p14:sldId id="256"/>
             <p14:sldId id="257"/>
@@ -135,28 +135,28 @@
             <p14:sldId id="259"/>
           </p14:sldIdLst>
         </p14:section>
-        <p14:section name="The satellites" id="{36f4b2e8-185e-836f-ec15-7966a2d9b702}">
+        <p14:section name="The satellites" id="{6341b1b3-8d9f-6374-326b-68f42ca05fc6}">
           <p14:sldIdLst>
             <p14:sldId id="260"/>
             <p14:sldId id="261"/>
             <p14:sldId id="262"/>
           </p14:sldIdLst>
         </p14:section>
-        <p14:section name="Study and method" id="{605ca566-8139-aeb0-cd9a-e187ddfe1808}">
+        <p14:section name="Study and method" id="{cec30c08-7fc8-29b7-d9d6-6d1ed1a64b5b}">
           <p14:sldIdLst>
             <p14:sldId id="263"/>
             <p14:sldId id="264"/>
             <p14:sldId id="265"/>
           </p14:sldIdLst>
         </p14:section>
-        <p14:section name="Evidence" id="{43a5f231-0145-a545-a9d9-e158ade9b0b2}">
+        <p14:section name="Evidence" id="{d575cb99-b694-f74a-3146-9f6fea1ed83d}">
           <p14:sldIdLst>
             <p14:sldId id="266"/>
             <p14:sldId id="267"/>
             <p14:sldId id="268"/>
           </p14:sldIdLst>
         </p14:section>
-        <p14:section name="Plan" id="{a4f3036b-b7c9-19e6-eefd-33bf7911b125}">
+        <p14:section name="Plan" id="{370aa6a0-fe83-f063-c81c-f39cb5cfa854}">
           <p14:sldIdLst>
             <p14:sldId id="269"/>
             <p14:sldId id="270"/>
@@ -8094,7 +8094,7 @@
                   <a:schemeClr val="tx1"/>
                 </a:solidFill>
               </a:rPr>
-              <a:t>How accurate is SWOT on reservoirs and village tanks, and can a learned model tell which readings to trust better than SWOT's own flags?</a:t>
+              <a:t>How accurate is SWOT on reservoirs and village tanks, and how many "suspect" readings can a learned screen keep?</a:t>
             </a:r>
             <a:endParaRPr lang="en-US" sz="1600" dirty="0"/>
           </a:p>
@@ -8130,7 +8130,7 @@
                   <a:schemeClr val="accent6"/>
                 </a:solidFill>
               </a:rPr>
-              <a:t>Measured by error in cm against gauges, on reservoirs the model never saw</a:t>
+              <a:t>Measured by error in cm against gauges, on reservoirs the screen never saw</a:t>
             </a:r>
             <a:endParaRPr lang="en-US" sz="1150" dirty="0"/>
           </a:p>
@@ -8257,7 +8257,7 @@
                   <a:schemeClr val="tx1"/>
                 </a:solidFill>
               </a:rPr>
-              <a:t>Does AI water area plus SWOT height give storage close to official and measured values?</a:t>
+              <a:t>Can a model trained on about 100 gauged reservoirs turn SWOT height and water area into % full, for tanks it never saw?</a:t>
             </a:r>
             <a:endParaRPr lang="en-US" sz="1600" dirty="0"/>
           </a:p>
@@ -8293,7 +8293,7 @@
                   <a:schemeClr val="accent6"/>
                 </a:solidFill>
               </a:rPr>
-              <a:t>Measured by error as a % of capacity</a:t>
+              <a:t>Measured by error in % of capacity, on reservoirs it never saw</a:t>
             </a:r>
             <a:endParaRPr lang="en-US" sz="1150" dirty="0"/>
           </a:p>
@@ -8600,7 +8600,7 @@
                   <a:schemeClr val="accent6"/>
                 </a:solidFill>
               </a:rPr>
-              <a:t>Each of us owns a research question from start to finish, and trains one model for it.</a:t>
+              <a:t>Three models in one chain: A finds where the water is, B how much there is, and C what comes next.</a:t>
             </a:r>
             <a:endParaRPr lang="en-US" sz="1400" dirty="0"/>
           </a:p>
@@ -8967,7 +8967,7 @@
                   <a:schemeClr val="tx1"/>
                 </a:solidFill>
               </a:rPr>
-              <a:t>water maps for all tanks</a:t>
+              <a:t>the water area of every tank</a:t>
             </a:r>
             <a:endParaRPr lang="en-US" sz="1250" dirty="0"/>
           </a:p>
@@ -9125,7 +9125,7 @@
                 <a:ea typeface="+mj-lt" pitchFamily="34" charset="-122"/>
                 <a:cs typeface="+mj-lt" pitchFamily="34" charset="-120"/>
               </a:rPr>
-              <a:t>SWOT and gauges</a:t>
+              <a:t>SWOT and storage</a:t>
             </a:r>
             <a:endParaRPr lang="en-US" sz="1900" dirty="0"/>
           </a:p>
@@ -9196,7 +9196,70 @@
       </p:sp>
       <p:sp>
         <p:nvSpPr>
-          <p:cNvPr id="21" name="Text 17"/>
+          <p:cNvPr id="21" name="RQ3"/>
+          <p:cNvSpPr/>
+          <p:nvPr/>
+        </p:nvSpPr>
+        <p:spPr>
+          <a:xfrm>
+            <a:off x="5347106" y="2926080"/>
+            <a:ext cx="640080" cy="310896"/>
+          </a:xfrm>
+          <a:prstGeom prst="roundRect">
+            <a:avLst>
+              <a:gd name="adj" fmla="val 23529"/>
+            </a:avLst>
+          </a:prstGeom>
+          <a:solidFill>
+            <a:schemeClr val="accent3"/>
+          </a:solidFill>
+          <a:ln w="12700">
+            <a:solidFill>
+              <a:schemeClr val="accent3"/>
+            </a:solidFill>
+            <a:prstDash val="solid"/>
+          </a:ln>
+        </p:spPr>
+      </p:sp>
+      <p:sp>
+        <p:nvSpPr>
+          <p:cNvPr id="22" name="Text 18"/>
+          <p:cNvSpPr txBox="1"/>
+          <p:nvPr/>
+        </p:nvSpPr>
+        <p:spPr>
+          <a:xfrm>
+            <a:off x="5347106" y="2926080"/>
+            <a:ext cx="640080" cy="310896"/>
+          </a:xfrm>
+          <a:prstGeom prst="rect">
+            <a:avLst/>
+          </a:prstGeom>
+          <a:noFill/>
+          <a:ln/>
+        </p:spPr>
+        <p:txBody>
+          <a:bodyPr wrap="square" lIns="0" tIns="0" rIns="0" bIns="0" rtlCol="0" anchor="ctr"/>
+          <a:lstStyle/>
+          <a:p>
+            <a:pPr algn="ctr" indent="0" marL="0">
+              <a:buNone/>
+            </a:pPr>
+            <a:r>
+              <a:rPr lang="en-US" sz="1200" b="1" dirty="0">
+                <a:solidFill>
+                  <a:schemeClr val="bg1"/>
+                </a:solidFill>
+              </a:rPr>
+              <a:t>RQ3</a:t>
+            </a:r>
+            <a:endParaRPr lang="en-US" sz="1200" dirty="0"/>
+          </a:p>
+        </p:txBody>
+      </p:sp>
+      <p:sp>
+        <p:nvSpPr>
+          <p:cNvPr id="23" name="Text 19"/>
           <p:cNvSpPr txBox="1"/>
           <p:nvPr/>
         </p:nvSpPr>
@@ -9228,7 +9291,7 @@
                   <a:schemeClr val="tx1"/>
                 </a:solidFill>
               </a:rPr>
-              <a:t>SWOT heights from Hydrocron, checked against gauges</a:t>
+              <a:t>SWOT heights, checked against gauges</a:t>
             </a:r>
             <a:endParaRPr lang="en-US" sz="1400" dirty="0"/>
           </a:p>
@@ -9246,7 +9309,7 @@
                   <a:schemeClr val="tx1"/>
                 </a:solidFill>
               </a:rPr>
-              <a:t>Gauge data: daily records and history</a:t>
+              <a:t>A trust screen that cleans every reading</a:t>
             </a:r>
             <a:endParaRPr lang="en-US" sz="1400" dirty="0"/>
           </a:p>
@@ -9264,7 +9327,7 @@
                   <a:schemeClr val="tx1"/>
                 </a:solidFill>
               </a:rPr>
-              <a:t>Model: a SWOT trust model (gradient boosting)</a:t>
+              <a:t>Model: % full from height and area (gradient boosting)</a:t>
             </a:r>
             <a:endParaRPr lang="en-US" sz="1400" dirty="0"/>
           </a:p>
@@ -9272,7 +9335,7 @@
       </p:sp>
       <p:sp>
         <p:nvSpPr>
-          <p:cNvPr id="22" name="divider"/>
+          <p:cNvPr id="24" name="divider"/>
           <p:cNvSpPr/>
           <p:nvPr/>
         </p:nvSpPr>
@@ -9295,7 +9358,7 @@
       </p:sp>
       <p:sp>
         <p:nvSpPr>
-          <p:cNvPr id="23" name="Text 19"/>
+          <p:cNvPr id="25" name="Text 21"/>
           <p:cNvSpPr txBox="1"/>
           <p:nvPr/>
         </p:nvSpPr>
@@ -9334,7 +9397,7 @@
                   <a:schemeClr val="tx1"/>
                 </a:solidFill>
               </a:rPr>
-              <a:t>accuracy report and trust model</a:t>
+              <a:t>how full every tank is</a:t>
             </a:r>
             <a:endParaRPr lang="en-US" sz="1250" dirty="0"/>
           </a:p>
@@ -9342,7 +9405,7 @@
       </p:sp>
       <p:sp>
         <p:nvSpPr>
-          <p:cNvPr id="24" name="MEMBER C"/>
+          <p:cNvPr id="26" name="MEMBER C"/>
           <p:cNvSpPr/>
           <p:nvPr/>
         </p:nvSpPr>
@@ -9376,7 +9439,7 @@
       </p:sp>
       <p:sp>
         <p:nvSpPr>
-          <p:cNvPr id="25" name="icon FaChartLine"/>
+          <p:cNvPr id="27" name="icon FaChartLine"/>
           <p:cNvSpPr/>
           <p:nvPr/>
         </p:nvSpPr>
@@ -9401,7 +9464,7 @@
       </p:sp>
       <p:pic>
         <p:nvPicPr>
-          <p:cNvPr id="26" name="Image 2" descr="preencoded.png">    </p:cNvPr>
+          <p:cNvPr id="28" name="Image 2" descr="preencoded.png">    </p:cNvPr>
           <p:cNvPicPr>
             <a:picLocks noChangeAspect="1"/>
           </p:cNvPicPr>
@@ -9425,7 +9488,7 @@
       </p:pic>
       <p:sp>
         <p:nvSpPr>
-          <p:cNvPr id="27" name="Text 22"/>
+          <p:cNvPr id="29" name="Text 24"/>
           <p:cNvSpPr txBox="1"/>
           <p:nvPr/>
         </p:nvSpPr>
@@ -9461,7 +9524,7 @@
       </p:sp>
       <p:sp>
         <p:nvSpPr>
-          <p:cNvPr id="28" name="Text 23"/>
+          <p:cNvPr id="30" name="Text 25"/>
           <p:cNvSpPr txBox="1"/>
           <p:nvPr/>
         </p:nvSpPr>
@@ -9492,7 +9555,7 @@
                 <a:ea typeface="+mj-lt" pitchFamily="34" charset="-122"/>
                 <a:cs typeface="+mj-lt" pitchFamily="34" charset="-120"/>
               </a:rPr>
-              <a:t>Storage and forecast</a:t>
+              <a:t>Forecast and system</a:t>
             </a:r>
             <a:endParaRPr lang="en-US" sz="1900" dirty="0"/>
           </a:p>
@@ -9500,7 +9563,7 @@
       </p:sp>
       <p:sp>
         <p:nvSpPr>
-          <p:cNvPr id="29" name="RQ3"/>
+          <p:cNvPr id="31" name="RQ4"/>
           <p:cNvSpPr/>
           <p:nvPr/>
         </p:nvSpPr>
@@ -9527,76 +9590,13 @@
       </p:sp>
       <p:sp>
         <p:nvSpPr>
-          <p:cNvPr id="30" name="Text 25"/>
+          <p:cNvPr id="32" name="Text 27"/>
           <p:cNvSpPr txBox="1"/>
           <p:nvPr/>
         </p:nvSpPr>
         <p:spPr>
           <a:xfrm>
             <a:off x="8371637" y="2926080"/>
-            <a:ext cx="640080" cy="310896"/>
-          </a:xfrm>
-          <a:prstGeom prst="rect">
-            <a:avLst/>
-          </a:prstGeom>
-          <a:noFill/>
-          <a:ln/>
-        </p:spPr>
-        <p:txBody>
-          <a:bodyPr wrap="square" lIns="0" tIns="0" rIns="0" bIns="0" rtlCol="0" anchor="ctr"/>
-          <a:lstStyle/>
-          <a:p>
-            <a:pPr algn="ctr" indent="0" marL="0">
-              <a:buNone/>
-            </a:pPr>
-            <a:r>
-              <a:rPr lang="en-US" sz="1200" b="1" dirty="0">
-                <a:solidFill>
-                  <a:schemeClr val="bg1"/>
-                </a:solidFill>
-              </a:rPr>
-              <a:t>RQ3</a:t>
-            </a:r>
-            <a:endParaRPr lang="en-US" sz="1200" dirty="0"/>
-          </a:p>
-        </p:txBody>
-      </p:sp>
-      <p:sp>
-        <p:nvSpPr>
-          <p:cNvPr id="31" name="RQ4"/>
-          <p:cNvSpPr/>
-          <p:nvPr/>
-        </p:nvSpPr>
-        <p:spPr>
-          <a:xfrm>
-            <a:off x="9121445" y="2926080"/>
-            <a:ext cx="640080" cy="310896"/>
-          </a:xfrm>
-          <a:prstGeom prst="roundRect">
-            <a:avLst>
-              <a:gd name="adj" fmla="val 23529"/>
-            </a:avLst>
-          </a:prstGeom>
-          <a:solidFill>
-            <a:schemeClr val="accent2"/>
-          </a:solidFill>
-          <a:ln w="12700">
-            <a:solidFill>
-              <a:schemeClr val="accent2"/>
-            </a:solidFill>
-            <a:prstDash val="solid"/>
-          </a:ln>
-        </p:spPr>
-      </p:sp>
-      <p:sp>
-        <p:nvSpPr>
-          <p:cNvPr id="32" name="Text 27"/>
-          <p:cNvSpPr txBox="1"/>
-          <p:nvPr/>
-        </p:nvSpPr>
-        <p:spPr>
-          <a:xfrm>
-            <a:off x="9121445" y="2926080"/>
             <a:ext cx="640080" cy="310896"/>
           </a:xfrm>
           <a:prstGeom prst="rect">
@@ -9658,7 +9658,7 @@
                   <a:schemeClr val="tx1"/>
                 </a:solidFill>
               </a:rPr>
-              <a:t>Height–area–volume curve for each tank</a:t>
+              <a:t>Daily storage of 117 reservoirs, rain and evaporation</a:t>
             </a:r>
             <a:endParaRPr lang="en-US" sz="1400" dirty="0"/>
           </a:p>
@@ -9676,7 +9676,7 @@
                   <a:schemeClr val="tx1"/>
                 </a:solidFill>
               </a:rPr>
-              <a:t>Storage every 5–12 days, checked against official figures</a:t>
+              <a:t>The chain from picture to forecast, after every pass</a:t>
             </a:r>
             <a:endParaRPr lang="en-US" sz="1400" dirty="0"/>
           </a:p>
@@ -9764,7 +9764,7 @@
                   <a:schemeClr val="tx1"/>
                 </a:solidFill>
               </a:rPr>
-              <a:t>storage, forecast and dashboard</a:t>
+              <a:t>the forecast and the dashboard</a:t>
             </a:r>
             <a:endParaRPr lang="en-US" sz="1250" dirty="0"/>
           </a:p>
@@ -10732,7 +10732,7 @@
                   <a:schemeClr val="tx1"/>
                 </a:solidFill>
               </a:rPr>
-              <a:t>Member B: SWOT and gauges</a:t>
+              <a:t>Member B: SWOT and storage</a:t>
             </a:r>
             <a:endParaRPr lang="en-US" sz="3400" dirty="0"/>
           </a:p>
@@ -10803,14 +10803,41 @@
       </p:sp>
       <p:sp>
         <p:nvSpPr>
-          <p:cNvPr id="5" name="Text 3"/>
-          <p:cNvSpPr txBox="1"/>
-          <p:nvPr/>
-        </p:nvSpPr>
-        <p:spPr>
-          <a:xfrm>
-            <a:off x="1389888" y="1161288"/>
-            <a:ext cx="10253167" cy="411480"/>
+          <p:cNvPr id="5" name="RQ3"/>
+          <p:cNvSpPr/>
+          <p:nvPr/>
+        </p:nvSpPr>
+        <p:spPr>
+          <a:xfrm>
+            <a:off x="1298448" y="1207008"/>
+            <a:ext cx="640080" cy="310896"/>
+          </a:xfrm>
+          <a:prstGeom prst="roundRect">
+            <a:avLst>
+              <a:gd name="adj" fmla="val 23529"/>
+            </a:avLst>
+          </a:prstGeom>
+          <a:solidFill>
+            <a:schemeClr val="accent3"/>
+          </a:solidFill>
+          <a:ln w="12700">
+            <a:solidFill>
+              <a:schemeClr val="accent3"/>
+            </a:solidFill>
+            <a:prstDash val="solid"/>
+          </a:ln>
+        </p:spPr>
+      </p:sp>
+      <p:sp>
+        <p:nvSpPr>
+          <p:cNvPr id="6" name="Text 4"/>
+          <p:cNvSpPr txBox="1"/>
+          <p:nvPr/>
+        </p:nvSpPr>
+        <p:spPr>
+          <a:xfrm>
+            <a:off x="1298448" y="1207008"/>
+            <a:ext cx="640080" cy="310896"/>
           </a:xfrm>
           <a:prstGeom prst="rect">
             <a:avLst/>
@@ -10822,6 +10849,42 @@
           <a:bodyPr wrap="square" lIns="0" tIns="0" rIns="0" bIns="0" rtlCol="0" anchor="ctr"/>
           <a:lstStyle/>
           <a:p>
+            <a:pPr algn="ctr" indent="0" marL="0">
+              <a:buNone/>
+            </a:pPr>
+            <a:r>
+              <a:rPr lang="en-US" sz="1200" b="1" dirty="0">
+                <a:solidFill>
+                  <a:schemeClr val="bg1"/>
+                </a:solidFill>
+              </a:rPr>
+              <a:t>RQ3</a:t>
+            </a:r>
+            <a:endParaRPr lang="en-US" sz="1200" dirty="0"/>
+          </a:p>
+        </p:txBody>
+      </p:sp>
+      <p:sp>
+        <p:nvSpPr>
+          <p:cNvPr id="7" name="Text 5"/>
+          <p:cNvSpPr txBox="1"/>
+          <p:nvPr/>
+        </p:nvSpPr>
+        <p:spPr>
+          <a:xfrm>
+            <a:off x="2139696" y="1161288"/>
+            <a:ext cx="9503359" cy="411480"/>
+          </a:xfrm>
+          <a:prstGeom prst="rect">
+            <a:avLst/>
+          </a:prstGeom>
+          <a:noFill/>
+          <a:ln/>
+        </p:spPr>
+        <p:txBody>
+          <a:bodyPr wrap="square" lIns="0" tIns="0" rIns="0" bIns="0" rtlCol="0" anchor="ctr"/>
+          <a:lstStyle/>
+          <a:p>
             <a:pPr indent="0" marL="0">
               <a:buNone/>
             </a:pPr>
@@ -10831,7 +10894,7 @@
                   <a:schemeClr val="accent6"/>
                 </a:solidFill>
               </a:rPr>
-              <a:t>How accurate is SWOT on reservoirs and village tanks, and can a learned model tell which readings to trust better than SWOT's own flags?</a:t>
+              <a:t>How accurate is SWOT, and can a model trained on about 100 reservoirs turn SWOT height and water area into % full for new tanks?</a:t>
             </a:r>
             <a:endParaRPr lang="en-US" sz="1400" dirty="0"/>
           </a:p>
@@ -10839,7 +10902,7 @@
       </p:sp>
       <p:sp>
         <p:nvSpPr>
-          <p:cNvPr id="6" name="Data analysis"/>
+          <p:cNvPr id="8" name="Data analysis"/>
           <p:cNvSpPr/>
           <p:nvPr/>
         </p:nvSpPr>
@@ -10866,7 +10929,7 @@
       </p:sp>
       <p:sp>
         <p:nvSpPr>
-          <p:cNvPr id="7" name="icon FaChartColumn"/>
+          <p:cNvPr id="9" name="icon FaChartColumn"/>
           <p:cNvSpPr/>
           <p:nvPr/>
         </p:nvSpPr>
@@ -10891,7 +10954,7 @@
       </p:sp>
       <p:pic>
         <p:nvPicPr>
-          <p:cNvPr id="8" name="Image 0" descr="preencoded.png">    </p:cNvPr>
+          <p:cNvPr id="10" name="Image 0" descr="preencoded.png">    </p:cNvPr>
           <p:cNvPicPr>
             <a:picLocks noChangeAspect="1"/>
           </p:cNvPicPr>
@@ -10915,7 +10978,7 @@
       </p:pic>
       <p:sp>
         <p:nvSpPr>
-          <p:cNvPr id="9" name="Text 6"/>
+          <p:cNvPr id="11" name="Text 8"/>
           <p:cNvSpPr txBox="1"/>
           <p:nvPr/>
         </p:nvSpPr>
@@ -10954,7 +11017,7 @@
       </p:sp>
       <p:sp>
         <p:nvSpPr>
-          <p:cNvPr id="10" name="Text 7"/>
+          <p:cNvPr id="12" name="Text 9"/>
           <p:cNvSpPr txBox="1"/>
           <p:nvPr/>
         </p:nvSpPr>
@@ -10986,7 +11049,7 @@
                   <a:schemeClr val="tx1"/>
                 </a:solidFill>
               </a:rPr>
-              <a:t>SWOT minus gauge on every pass: the average gap and the spread in cm</a:t>
+              <a:t>SWOT minus gauge on every pass: the steady gap and the spread in cm</a:t>
             </a:r>
             <a:endParaRPr lang="en-US" sz="1500" dirty="0"/>
           </a:p>
@@ -11004,7 +11067,7 @@
                   <a:schemeClr val="tx1"/>
                 </a:solidFill>
               </a:rPr>
-              <a:t>Labels for the model: each reading's error at the 117 department reservoirs</a:t>
+              <a:t>Trust screen: how many "suspect" readings it keeps, and their error</a:t>
             </a:r>
             <a:endParaRPr lang="en-US" sz="1500" dirty="0"/>
           </a:p>
@@ -11022,7 +11085,7 @@
                   <a:schemeClr val="tx1"/>
                 </a:solidFill>
               </a:rPr>
-              <a:t>The trust model against SWOT's own flags, on reservoirs it never saw</a:t>
+              <a:t>Training pairs: daily storage with SWOT height and water area, at about 100 reservoirs</a:t>
             </a:r>
             <a:endParaRPr lang="en-US" sz="1500" dirty="0"/>
           </a:p>
@@ -11040,7 +11103,7 @@
                   <a:schemeClr val="tx1"/>
                 </a:solidFill>
               </a:rPr>
-              <a:t>How a height error turns into a volume error</a:t>
+              <a:t>Storage error in % of capacity on reservoirs the model never saw, against one formula and Imbulana's equation</a:t>
             </a:r>
             <a:endParaRPr lang="en-US" sz="1500" dirty="0"/>
           </a:p>
@@ -11048,7 +11111,7 @@
       </p:sp>
       <p:sp>
         <p:nvSpPr>
-          <p:cNvPr id="11" name="Technical work"/>
+          <p:cNvPr id="13" name="Technical work"/>
           <p:cNvSpPr/>
           <p:nvPr/>
         </p:nvSpPr>
@@ -11082,7 +11145,7 @@
       </p:sp>
       <p:sp>
         <p:nvSpPr>
-          <p:cNvPr id="12" name="icon FaGears"/>
+          <p:cNvPr id="14" name="icon FaGears"/>
           <p:cNvSpPr/>
           <p:nvPr/>
         </p:nvSpPr>
@@ -11107,7 +11170,7 @@
       </p:sp>
       <p:pic>
         <p:nvPicPr>
-          <p:cNvPr id="13" name="Image 1" descr="preencoded.png">    </p:cNvPr>
+          <p:cNvPr id="15" name="Image 1" descr="preencoded.png">    </p:cNvPr>
           <p:cNvPicPr>
             <a:picLocks noChangeAspect="1"/>
           </p:cNvPicPr>
@@ -11131,7 +11194,7 @@
       </p:pic>
       <p:sp>
         <p:nvSpPr>
-          <p:cNvPr id="14" name="Text 10"/>
+          <p:cNvPr id="16" name="Text 12"/>
           <p:cNvSpPr txBox="1"/>
           <p:nvPr/>
         </p:nvSpPr>
@@ -11170,7 +11233,7 @@
       </p:sp>
       <p:sp>
         <p:nvSpPr>
-          <p:cNvPr id="15" name="Text 11"/>
+          <p:cNvPr id="17" name="Text 13"/>
           <p:cNvSpPr txBox="1"/>
           <p:nvPr/>
         </p:nvSpPr>
@@ -11220,7 +11283,7 @@
                   <a:schemeClr val="tx1"/>
                 </a:solidFill>
               </a:rPr>
-              <a:t>Trust model: gradient boosting (XGBoost or LightGBM) on SWOT's quality fields, track distance, lake size and season</a:t>
+              <a:t>Trust screen: gradient boosting on SWOT's quality fields, track distance, lake size and season</a:t>
             </a:r>
             <a:endParaRPr lang="en-US" sz="1500" dirty="0"/>
           </a:p>
@@ -11238,7 +11301,7 @@
                   <a:schemeClr val="tx1"/>
                 </a:solidFill>
               </a:rPr>
-              <a:t>Gauge zero in metres above sea level: full supply level minus full supply depth</a:t>
+              <a:t>Storage model: gradient boosting in which more height or area never means less water</a:t>
             </a:r>
             <a:endParaRPr lang="en-US" sz="1500" dirty="0"/>
           </a:p>
@@ -11256,7 +11319,7 @@
                   <a:schemeClr val="tx1"/>
                 </a:solidFill>
               </a:rPr>
-              <a:t>Daily logger for the department's sheet; storage history turned back into gauge heights</a:t>
+              <a:t>Inputs every tank has: height, area, outline, catchment and slope (Copernicus DEM)</a:t>
             </a:r>
             <a:endParaRPr lang="en-US" sz="1500" dirty="0"/>
           </a:p>
@@ -11264,7 +11327,7 @@
       </p:sp>
       <p:sp>
         <p:nvSpPr>
-          <p:cNvPr id="16" name="output"/>
+          <p:cNvPr id="18" name="output"/>
           <p:cNvSpPr/>
           <p:nvPr/>
         </p:nvSpPr>
@@ -11291,7 +11354,7 @@
       </p:sp>
       <p:sp>
         <p:nvSpPr>
-          <p:cNvPr id="17" name="icon FaFlagCheckered"/>
+          <p:cNvPr id="19" name="icon FaFlagCheckered"/>
           <p:cNvSpPr/>
           <p:nvPr/>
         </p:nvSpPr>
@@ -11316,7 +11379,7 @@
       </p:sp>
       <p:pic>
         <p:nvPicPr>
-          <p:cNvPr id="18" name="Image 2" descr="preencoded.png">    </p:cNvPr>
+          <p:cNvPr id="20" name="Image 2" descr="preencoded.png">    </p:cNvPr>
           <p:cNvPicPr>
             <a:picLocks noChangeAspect="1"/>
           </p:cNvPicPr>
@@ -11340,7 +11403,7 @@
       </p:pic>
       <p:sp>
         <p:nvSpPr>
-          <p:cNvPr id="19" name="Text 14"/>
+          <p:cNvPr id="21" name="Text 16"/>
           <p:cNvSpPr txBox="1"/>
           <p:nvPr/>
         </p:nvSpPr>
@@ -11379,7 +11442,7 @@
                   <a:schemeClr val="bg1"/>
                 </a:solidFill>
               </a:rPr>
-              <a:t>SWOT accuracy report, the fixed gap for each reservoir, and a trust model that scores every reading</a:t>
+              <a:t>SWOT accuracy report, a screen that cleans every reading, and a model that says how full any tank is</a:t>
             </a:r>
             <a:endParaRPr lang="en-US" sz="1500" dirty="0"/>
           </a:p>
@@ -11487,7 +11550,7 @@
                   <a:schemeClr val="tx1"/>
                 </a:solidFill>
               </a:rPr>
-              <a:t>Member C: Storage and forecast</a:t>
+              <a:t>Member C: Forecast and system</a:t>
             </a:r>
             <a:endParaRPr lang="en-US" sz="3400" dirty="0"/>
           </a:p>
@@ -11495,7 +11558,7 @@
       </p:sp>
       <p:sp>
         <p:nvSpPr>
-          <p:cNvPr id="3" name="RQ3"/>
+          <p:cNvPr id="3" name="RQ4"/>
           <p:cNvSpPr/>
           <p:nvPr/>
         </p:nvSpPr>
@@ -11550,7 +11613,7 @@
                   <a:schemeClr val="bg1"/>
                 </a:solidFill>
               </a:rPr>
-              <a:t>RQ3</a:t>
+              <a:t>RQ4</a:t>
             </a:r>
             <a:endParaRPr lang="en-US" sz="1200" dirty="0"/>
           </a:p>
@@ -11558,19 +11621,80 @@
       </p:sp>
       <p:sp>
         <p:nvSpPr>
-          <p:cNvPr id="5" name="RQ4"/>
+          <p:cNvPr id="5" name="Text 3"/>
+          <p:cNvSpPr txBox="1"/>
+          <p:nvPr/>
+        </p:nvSpPr>
+        <p:spPr>
+          <a:xfrm>
+            <a:off x="1389888" y="1161288"/>
+            <a:ext cx="10253167" cy="411480"/>
+          </a:xfrm>
+          <a:prstGeom prst="rect">
+            <a:avLst/>
+          </a:prstGeom>
+          <a:noFill/>
+          <a:ln/>
+        </p:spPr>
+        <p:txBody>
+          <a:bodyPr wrap="square" lIns="0" tIns="0" rIns="0" bIns="0" rtlCol="0" anchor="ctr"/>
+          <a:lstStyle/>
+          <a:p>
+            <a:pPr indent="0" marL="0">
+              <a:buNone/>
+            </a:pPr>
+            <a:r>
+              <a:rPr lang="en-US" sz="1400" dirty="0">
+                <a:solidFill>
+                  <a:schemeClr val="accent6"/>
+                </a:solidFill>
+              </a:rPr>
+              <a:t>Can a deep-learning model forecast each tank's storage 2–4 weeks ahead, from recent storage, rain and evaporation, better than "no change"?</a:t>
+            </a:r>
+            <a:endParaRPr lang="en-US" sz="1400" dirty="0"/>
+          </a:p>
+        </p:txBody>
+      </p:sp>
+      <p:sp>
+        <p:nvSpPr>
+          <p:cNvPr id="6" name="Data analysis"/>
           <p:cNvSpPr/>
           <p:nvPr/>
         </p:nvSpPr>
         <p:spPr>
           <a:xfrm>
-            <a:off x="1298448" y="1207008"/>
-            <a:ext cx="640080" cy="310896"/>
+            <a:off x="548640" y="1783080"/>
+            <a:ext cx="5410048" cy="3611880"/>
           </a:xfrm>
           <a:prstGeom prst="roundRect">
             <a:avLst>
-              <a:gd name="adj" fmla="val 23529"/>
+              <a:gd name="adj" fmla="val 3038"/>
             </a:avLst>
+          </a:prstGeom>
+          <a:solidFill>
+            <a:schemeClr val="bg2"/>
+          </a:solidFill>
+          <a:ln w="9525">
+            <a:solidFill>
+              <a:schemeClr val="bg2"/>
+            </a:solidFill>
+            <a:prstDash val="solid"/>
+          </a:ln>
+        </p:spPr>
+      </p:sp>
+      <p:sp>
+        <p:nvSpPr>
+          <p:cNvPr id="7" name="icon FaChartColumn"/>
+          <p:cNvSpPr/>
+          <p:nvPr/>
+        </p:nvSpPr>
+        <p:spPr>
+          <a:xfrm>
+            <a:off x="822960" y="1947672"/>
+            <a:ext cx="457200" cy="457200"/>
+          </a:xfrm>
+          <a:prstGeom prst="ellipse">
+            <a:avLst/>
           </a:prstGeom>
           <a:solidFill>
             <a:schemeClr val="accent2"/>
@@ -11583,133 +11707,9 @@
           </a:ln>
         </p:spPr>
       </p:sp>
-      <p:sp>
-        <p:nvSpPr>
-          <p:cNvPr id="6" name="Text 4"/>
-          <p:cNvSpPr txBox="1"/>
-          <p:nvPr/>
-        </p:nvSpPr>
-        <p:spPr>
-          <a:xfrm>
-            <a:off x="1298448" y="1207008"/>
-            <a:ext cx="640080" cy="310896"/>
-          </a:xfrm>
-          <a:prstGeom prst="rect">
-            <a:avLst/>
-          </a:prstGeom>
-          <a:noFill/>
-          <a:ln/>
-        </p:spPr>
-        <p:txBody>
-          <a:bodyPr wrap="square" lIns="0" tIns="0" rIns="0" bIns="0" rtlCol="0" anchor="ctr"/>
-          <a:lstStyle/>
-          <a:p>
-            <a:pPr algn="ctr" indent="0" marL="0">
-              <a:buNone/>
-            </a:pPr>
-            <a:r>
-              <a:rPr lang="en-US" sz="1200" b="1" dirty="0">
-                <a:solidFill>
-                  <a:schemeClr val="bg1"/>
-                </a:solidFill>
-              </a:rPr>
-              <a:t>RQ4</a:t>
-            </a:r>
-            <a:endParaRPr lang="en-US" sz="1200" dirty="0"/>
-          </a:p>
-        </p:txBody>
-      </p:sp>
-      <p:sp>
-        <p:nvSpPr>
-          <p:cNvPr id="7" name="Text 5"/>
-          <p:cNvSpPr txBox="1"/>
-          <p:nvPr/>
-        </p:nvSpPr>
-        <p:spPr>
-          <a:xfrm>
-            <a:off x="2139696" y="1161288"/>
-            <a:ext cx="9503359" cy="411480"/>
-          </a:xfrm>
-          <a:prstGeom prst="rect">
-            <a:avLst/>
-          </a:prstGeom>
-          <a:noFill/>
-          <a:ln/>
-        </p:spPr>
-        <p:txBody>
-          <a:bodyPr wrap="square" lIns="0" tIns="0" rIns="0" bIns="0" rtlCol="0" anchor="ctr"/>
-          <a:lstStyle/>
-          <a:p>
-            <a:pPr indent="0" marL="0">
-              <a:buNone/>
-            </a:pPr>
-            <a:r>
-              <a:rPr lang="en-US" sz="1400" dirty="0">
-                <a:solidFill>
-                  <a:schemeClr val="accent6"/>
-                </a:solidFill>
-              </a:rPr>
-              <a:t>Does AI water area plus SWOT height give storage close to official values, and can a deep-learning model forecast it 2–4 weeks ahead?</a:t>
-            </a:r>
-            <a:endParaRPr lang="en-US" sz="1400" dirty="0"/>
-          </a:p>
-        </p:txBody>
-      </p:sp>
-      <p:sp>
-        <p:nvSpPr>
-          <p:cNvPr id="8" name="Data analysis"/>
-          <p:cNvSpPr/>
-          <p:nvPr/>
-        </p:nvSpPr>
-        <p:spPr>
-          <a:xfrm>
-            <a:off x="548640" y="1783080"/>
-            <a:ext cx="5410048" cy="3611880"/>
-          </a:xfrm>
-          <a:prstGeom prst="roundRect">
-            <a:avLst>
-              <a:gd name="adj" fmla="val 3038"/>
-            </a:avLst>
-          </a:prstGeom>
-          <a:solidFill>
-            <a:schemeClr val="bg2"/>
-          </a:solidFill>
-          <a:ln w="9525">
-            <a:solidFill>
-              <a:schemeClr val="bg2"/>
-            </a:solidFill>
-            <a:prstDash val="solid"/>
-          </a:ln>
-        </p:spPr>
-      </p:sp>
-      <p:sp>
-        <p:nvSpPr>
-          <p:cNvPr id="9" name="icon FaChartColumn"/>
-          <p:cNvSpPr/>
-          <p:nvPr/>
-        </p:nvSpPr>
-        <p:spPr>
-          <a:xfrm>
-            <a:off x="822960" y="1947672"/>
-            <a:ext cx="457200" cy="457200"/>
-          </a:xfrm>
-          <a:prstGeom prst="ellipse">
-            <a:avLst/>
-          </a:prstGeom>
-          <a:solidFill>
-            <a:schemeClr val="accent2"/>
-          </a:solidFill>
-          <a:ln w="12700">
-            <a:solidFill>
-              <a:schemeClr val="accent2"/>
-            </a:solidFill>
-            <a:prstDash val="solid"/>
-          </a:ln>
-        </p:spPr>
-      </p:sp>
       <p:pic>
         <p:nvPicPr>
-          <p:cNvPr id="10" name="Image 0" descr="preencoded.png">    </p:cNvPr>
+          <p:cNvPr id="8" name="Image 0" descr="preencoded.png">    </p:cNvPr>
           <p:cNvPicPr>
             <a:picLocks noChangeAspect="1"/>
           </p:cNvPicPr>
@@ -11733,7 +11733,7 @@
       </p:pic>
       <p:sp>
         <p:nvSpPr>
-          <p:cNvPr id="11" name="Text 8"/>
+          <p:cNvPr id="9" name="Text 6"/>
           <p:cNvSpPr txBox="1"/>
           <p:nvPr/>
         </p:nvSpPr>
@@ -11772,7 +11772,7 @@
       </p:sp>
       <p:sp>
         <p:nvSpPr>
-          <p:cNvPr id="12" name="Text 9"/>
+          <p:cNvPr id="10" name="Text 7"/>
           <p:cNvSpPr txBox="1"/>
           <p:nvPr/>
         </p:nvSpPr>
@@ -11804,7 +11804,7 @@
                   <a:schemeClr val="tx1"/>
                 </a:solidFill>
               </a:rPr>
-              <a:t>Each tank's area–height curve A(h) from its dots</a:t>
+              <a:t>Seasonal average for each tank, from past years only</a:t>
             </a:r>
             <a:endParaRPr lang="en-US" sz="1500" dirty="0"/>
           </a:p>
@@ -11822,7 +11822,7 @@
                   <a:schemeClr val="tx1"/>
                 </a:solidFill>
               </a:rPr>
-              <a:t>Storage change against the department's daily storage</a:t>
+              <a:t>Forecast error at 1, 2 and 4 weeks, against "no change" and the seasonal average</a:t>
             </a:r>
             <a:endParaRPr lang="en-US" sz="1500" dirty="0"/>
           </a:p>
@@ -11840,7 +11840,7 @@
                   <a:schemeClr val="tx1"/>
                 </a:solidFill>
               </a:rPr>
-              <a:t>Test the method on Kanhindawewa's drone table, and against Imbulana's formula</a:t>
+              <a:t>Tested on years and reservoirs the model never saw</a:t>
             </a:r>
             <a:endParaRPr lang="en-US" sz="1500" dirty="0"/>
           </a:p>
@@ -11858,7 +11858,7 @@
                   <a:schemeClr val="tx1"/>
                 </a:solidFill>
               </a:rPr>
-              <a:t>Forecast error at 1, 2 and 4 weeks, against "no change" and the seasonal average</a:t>
+              <a:t>The whole chain, picture to forecast, at the village tanks and on Kanhindawewa's drone survey</a:t>
             </a:r>
             <a:endParaRPr lang="en-US" sz="1500" dirty="0"/>
           </a:p>
@@ -11866,7 +11866,7 @@
       </p:sp>
       <p:sp>
         <p:nvSpPr>
-          <p:cNvPr id="13" name="Technical work"/>
+          <p:cNvPr id="11" name="Technical work"/>
           <p:cNvSpPr/>
           <p:nvPr/>
         </p:nvSpPr>
@@ -11900,7 +11900,7 @@
       </p:sp>
       <p:sp>
         <p:nvSpPr>
-          <p:cNvPr id="14" name="icon FaGears"/>
+          <p:cNvPr id="12" name="icon FaGears"/>
           <p:cNvSpPr/>
           <p:nvPr/>
         </p:nvSpPr>
@@ -11925,7 +11925,7 @@
       </p:sp>
       <p:pic>
         <p:nvPicPr>
-          <p:cNvPr id="15" name="Image 1" descr="preencoded.png">    </p:cNvPr>
+          <p:cNvPr id="13" name="Image 1" descr="preencoded.png">    </p:cNvPr>
           <p:cNvPicPr>
             <a:picLocks noChangeAspect="1"/>
           </p:cNvPicPr>
@@ -11949,7 +11949,7 @@
       </p:pic>
       <p:sp>
         <p:nvSpPr>
-          <p:cNvPr id="16" name="Text 12"/>
+          <p:cNvPr id="14" name="Text 10"/>
           <p:cNvSpPr txBox="1"/>
           <p:nvPr/>
         </p:nvSpPr>
@@ -11988,7 +11988,7 @@
       </p:sp>
       <p:sp>
         <p:nvSpPr>
-          <p:cNvPr id="17" name="Text 13"/>
+          <p:cNvPr id="15" name="Text 11"/>
           <p:cNvSpPr txBox="1"/>
           <p:nvPr/>
         </p:nvSpPr>
@@ -12020,7 +12020,7 @@
                   <a:schemeClr val="tx1"/>
                 </a:solidFill>
               </a:rPr>
-              <a:t>Storage engine: dots, curve, thin layers and safe limits, after every pass</a:t>
+              <a:t>Forecast model: an LSTM with a gradient-boosting baseline, trained on 117 reservoirs' daily storage (2020–2026), rain and evaporation</a:t>
             </a:r>
             <a:endParaRPr lang="en-US" sz="1500" dirty="0"/>
           </a:p>
@@ -12038,7 +12038,7 @@
                   <a:schemeClr val="tx1"/>
                 </a:solidFill>
               </a:rPr>
-              <a:t>Forecast model: an LSTM with a gradient-boosting baseline, trained on 117 reservoirs' daily storage (2020–2026), rain and evaporation</a:t>
+              <a:t>The chain after every pass: A's water map and SWOT's height go into B's model</a:t>
             </a:r>
             <a:endParaRPr lang="en-US" sz="1500" dirty="0"/>
           </a:p>
@@ -12082,7 +12082,7 @@
       </p:sp>
       <p:sp>
         <p:nvSpPr>
-          <p:cNvPr id="18" name="output"/>
+          <p:cNvPr id="16" name="output"/>
           <p:cNvSpPr/>
           <p:nvPr/>
         </p:nvSpPr>
@@ -12109,7 +12109,7 @@
       </p:sp>
       <p:sp>
         <p:nvSpPr>
-          <p:cNvPr id="19" name="icon FaFlagCheckered"/>
+          <p:cNvPr id="17" name="icon FaFlagCheckered"/>
           <p:cNvSpPr/>
           <p:nvPr/>
         </p:nvSpPr>
@@ -12134,7 +12134,7 @@
       </p:sp>
       <p:pic>
         <p:nvPicPr>
-          <p:cNvPr id="20" name="Image 2" descr="preencoded.png">    </p:cNvPr>
+          <p:cNvPr id="18" name="Image 2" descr="preencoded.png">    </p:cNvPr>
           <p:cNvPicPr>
             <a:picLocks noChangeAspect="1"/>
           </p:cNvPicPr>
@@ -12158,7 +12158,7 @@
       </p:pic>
       <p:sp>
         <p:nvSpPr>
-          <p:cNvPr id="21" name="Text 16"/>
+          <p:cNvPr id="19" name="Text 14"/>
           <p:cNvSpPr txBox="1"/>
           <p:nvPr/>
         </p:nvSpPr>
@@ -12197,7 +12197,7 @@
                   <a:schemeClr val="bg1"/>
                 </a:solidFill>
               </a:rPr>
-              <a:t>storage for every tank with safe limits, and a 2–4 week forecast, on a dashboard</a:t>
+              <a:t>a 2–4 week forecast for every tank, the running chain and the dashboard</a:t>
             </a:r>
             <a:endParaRPr lang="en-US" sz="1500" dirty="0"/>
           </a:p>
@@ -12475,7 +12475,7 @@
                   <a:schemeClr val="tx1"/>
                 </a:solidFill>
               </a:rPr>
-              <a:t>A SWOT trust model that scores every reading</a:t>
+              <a:t>A SWOT trust screen, and a model that turns height and area into % full</a:t>
             </a:r>
             <a:endParaRPr lang="en-US" sz="1600" dirty="0"/>
           </a:p>
@@ -12560,7 +12560,7 @@
                   <a:schemeClr val="tx1"/>
                 </a:solidFill>
               </a:rPr>
-              <a:t>Curves and storage every 5–12 days for all 13 tanks</a:t>
+              <a:t>Storage every 5–12 days for all 13 tanks</a:t>
             </a:r>
             <a:endParaRPr lang="en-US" sz="1600" dirty="0"/>
           </a:p>
@@ -13080,7 +13080,7 @@
                   <a:schemeClr val="accent6"/>
                 </a:solidFill>
               </a:rPr>
-              <a:t>Labelled data, gauge readings, and the three models: water map, trust model, forecast</a:t>
+              <a:t>Labelled data, gauge readings, and the three models: water map, storage model, forecast</a:t>
             </a:r>
             <a:endParaRPr lang="en-US" sz="1250" dirty="0"/>
           </a:p>

</xml_diff>

<commit_message>
SWOT proposal approved: final proposal and talk
Both supervisors approved the SWOT Tank Water Tracker proposal. docs/proposals has the final proposal (29 Oct 2026): RQ3 compared with one area-storage formula, the cascade check, the Brazil SWOT filter and NASA's OPERA maps as baselines, IMERG for daily rain, and fixed ICITR and Madumalsha links. docs/presentation has the final talk without speaker notes. README status, decisions and the dataset list updated.
</commit_message>
<xml_diff>
--- a/docs/presentation/swot-tank-tracker-proposal-talk.pptx
+++ b/docs/presentation/swot-tank-tracker-proposal-talk.pptx
@@ -127,7 +127,7 @@
   <p:extLst>
     <p:ext uri="{521415D9-36F7-43E2-AB2F-B90AF26B5E84}">
       <p14:sectionLst xmlns:p14="http://schemas.microsoft.com/office/powerpoint/2010/main">
-        <p14:section name="Introduction" id="{3f6419a0-d7b3-caf8-cefb-36542fd2a945}">
+        <p14:section name="Introduction" id="{f81e3bdb-39ac-99b7-357a-9393e33d6931}">
           <p14:sldIdLst>
             <p14:sldId id="256"/>
             <p14:sldId id="257"/>
@@ -135,28 +135,28 @@
             <p14:sldId id="259"/>
           </p14:sldIdLst>
         </p14:section>
-        <p14:section name="The satellites" id="{6341b1b3-8d9f-6374-326b-68f42ca05fc6}">
+        <p14:section name="The satellites" id="{db251148-a154-e12f-6825-9dda8b65ed1c}">
           <p14:sldIdLst>
             <p14:sldId id="260"/>
             <p14:sldId id="261"/>
             <p14:sldId id="262"/>
           </p14:sldIdLst>
         </p14:section>
-        <p14:section name="Study and method" id="{cec30c08-7fc8-29b7-d9d6-6d1ed1a64b5b}">
+        <p14:section name="Study and method" id="{50a27b4f-4321-fbca-c55d-b142010bbaeb}">
           <p14:sldIdLst>
             <p14:sldId id="263"/>
             <p14:sldId id="264"/>
             <p14:sldId id="265"/>
           </p14:sldIdLst>
         </p14:section>
-        <p14:section name="Evidence" id="{d575cb99-b694-f74a-3146-9f6fea1ed83d}">
+        <p14:section name="Evidence" id="{91b74a35-f3f0-bee9-cf86-363ee21ce51e}">
           <p14:sldIdLst>
             <p14:sldId id="266"/>
             <p14:sldId id="267"/>
             <p14:sldId id="268"/>
           </p14:sldIdLst>
         </p14:section>
-        <p14:section name="Plan" id="{370aa6a0-fe83-f063-c81c-f39cb5cfa854}">
+        <p14:section name="Plan" id="{b7a470ed-8f5c-e574-ea44-a704798c720d}">
           <p14:sldIdLst>
             <p14:sldId id="269"/>
             <p14:sldId id="270"/>
@@ -11103,7 +11103,7 @@
                   <a:schemeClr val="tx1"/>
                 </a:solidFill>
               </a:rPr>
-              <a:t>Storage error in % of capacity on reservoirs the model never saw, against one formula and Imbulana's equation</a:t>
+              <a:t>Storage error in % of capacity on reservoirs the model never saw, against one formula for all tanks</a:t>
             </a:r>
             <a:endParaRPr lang="en-US" sz="1500" dirty="0"/>
           </a:p>
@@ -12980,7 +12980,7 @@
                   <a:schemeClr val="accent6"/>
                 </a:solidFill>
               </a:rPr>
-              <a:t>Study area confirmed after the cascade and name checks</a:t>
+              <a:t>Study area confirmed after the name check</a:t>
             </a:r>
             <a:endParaRPr lang="en-US" sz="1250" dirty="0"/>
           </a:p>
@@ -13882,7 +13882,7 @@
                   <a:schemeClr val="bg1"/>
                 </a:solidFill>
               </a:rPr>
-              <a:t>432 tanks of 6.25 ha or more in our study area (blue)</a:t>
+              <a:t>432 tanks of 6.25 ha or more on this map (blue)</a:t>
             </a:r>
             <a:endParaRPr lang="en-US" sz="1500" dirty="0"/>
           </a:p>
@@ -14564,46 +14564,7 @@
         </p:nvSpPr>
         <p:spPr>
           <a:xfrm>
-            <a:off x="6278728" y="1691640"/>
-            <a:ext cx="5364328" cy="329184"/>
-          </a:xfrm>
-          <a:prstGeom prst="rect">
-            <a:avLst/>
-          </a:prstGeom>
-          <a:noFill/>
-          <a:ln/>
-        </p:spPr>
-        <p:txBody>
-          <a:bodyPr wrap="square" lIns="0" tIns="0" rIns="0" bIns="0" rtlCol="0" anchor="ctr"/>
-          <a:lstStyle/>
-          <a:p>
-            <a:pPr indent="0" marL="0">
-              <a:buNone/>
-            </a:pPr>
-            <a:r>
-              <a:rPr lang="en-US" sz="1500" dirty="0">
-                <a:solidFill>
-                  <a:schemeClr val="tx1"/>
-                </a:solidFill>
-                <a:latin typeface="+mj-lt" pitchFamily="34" charset="0"/>
-                <a:ea typeface="+mj-lt" pitchFamily="34" charset="-122"/>
-                <a:cs typeface="+mj-lt" pitchFamily="34" charset="-120"/>
-              </a:rPr>
-              <a:t>Ground truth</a:t>
-            </a:r>
-            <a:endParaRPr lang="en-US" sz="1500" dirty="0"/>
-          </a:p>
-        </p:txBody>
-      </p:sp>
-      <p:sp>
-        <p:nvSpPr>
-          <p:cNvPr id="15" name="Text 13"/>
-          <p:cNvSpPr txBox="1"/>
-          <p:nvPr/>
-        </p:nvSpPr>
-        <p:spPr>
-          <a:xfrm>
-            <a:off x="6415888" y="2075688"/>
+            <a:off x="685800" y="5093208"/>
             <a:ext cx="5227168" cy="292608"/>
           </a:xfrm>
           <a:prstGeom prst="rect">
@@ -14632,7 +14593,7 @@
                   </a:extLst>
                 </a:hlinkClick>
               </a:rPr>
-              <a:t>Irrigation Department: reservoir water level</a:t>
+              <a:t>Global Water Watch archive</a:t>
             </a:r>
             <a:pPr indent="0" marL="0">
               <a:buNone/>
@@ -14643,7 +14604,7 @@
                   <a:schemeClr val="accent6"/>
                 </a:solidFill>
               </a:rPr>
-              <a:t>  the daily sheet</a:t>
+              <a:t>  reservoir water areas</a:t>
             </a:r>
             <a:endParaRPr lang="en-US" sz="1250" dirty="0"/>
           </a:p>
@@ -14651,13 +14612,52 @@
       </p:sp>
       <p:sp>
         <p:nvSpPr>
+          <p:cNvPr id="15" name="Text 13"/>
+          <p:cNvSpPr txBox="1"/>
+          <p:nvPr/>
+        </p:nvSpPr>
+        <p:spPr>
+          <a:xfrm>
+            <a:off x="548640" y="5550408"/>
+            <a:ext cx="5364328" cy="329184"/>
+          </a:xfrm>
+          <a:prstGeom prst="rect">
+            <a:avLst/>
+          </a:prstGeom>
+          <a:noFill/>
+          <a:ln/>
+        </p:spPr>
+        <p:txBody>
+          <a:bodyPr wrap="square" lIns="0" tIns="0" rIns="0" bIns="0" rtlCol="0" anchor="ctr"/>
+          <a:lstStyle/>
+          <a:p>
+            <a:pPr indent="0" marL="0">
+              <a:buNone/>
+            </a:pPr>
+            <a:r>
+              <a:rPr lang="en-US" sz="1500" dirty="0">
+                <a:solidFill>
+                  <a:schemeClr val="tx1"/>
+                </a:solidFill>
+                <a:latin typeface="+mj-lt" pitchFamily="34" charset="0"/>
+                <a:ea typeface="+mj-lt" pitchFamily="34" charset="-122"/>
+                <a:cs typeface="+mj-lt" pitchFamily="34" charset="-120"/>
+              </a:rPr>
+              <a:t>Ground shape</a:t>
+            </a:r>
+            <a:endParaRPr lang="en-US" sz="1500" dirty="0"/>
+          </a:p>
+        </p:txBody>
+      </p:sp>
+      <p:sp>
+        <p:nvSpPr>
           <p:cNvPr id="16" name="Text 14"/>
           <p:cNvSpPr txBox="1"/>
           <p:nvPr/>
         </p:nvSpPr>
         <p:spPr>
           <a:xfrm>
-            <a:off x="6415888" y="2386584"/>
+            <a:off x="685800" y="5934456"/>
             <a:ext cx="5227168" cy="292608"/>
           </a:xfrm>
           <a:prstGeom prst="rect">
@@ -14686,7 +14686,7 @@
                   </a:extLst>
                 </a:hlinkClick>
               </a:rPr>
-              <a:t>Irrigation Department: reservoir status</a:t>
+              <a:t>Copernicus DEM (GLO-30)</a:t>
             </a:r>
             <a:pPr indent="0" marL="0">
               <a:buNone/>
@@ -14697,7 +14697,7 @@
                   <a:schemeClr val="accent6"/>
                 </a:solidFill>
               </a:rPr>
-              <a:t>  web page</a:t>
+              <a:t>  30 m elevation map</a:t>
             </a:r>
             <a:endParaRPr lang="en-US" sz="1250" dirty="0"/>
           </a:p>
@@ -14711,7 +14711,46 @@
         </p:nvSpPr>
         <p:spPr>
           <a:xfrm>
-            <a:off x="6415888" y="2697480"/>
+            <a:off x="6278728" y="1691640"/>
+            <a:ext cx="5364328" cy="329184"/>
+          </a:xfrm>
+          <a:prstGeom prst="rect">
+            <a:avLst/>
+          </a:prstGeom>
+          <a:noFill/>
+          <a:ln/>
+        </p:spPr>
+        <p:txBody>
+          <a:bodyPr wrap="square" lIns="0" tIns="0" rIns="0" bIns="0" rtlCol="0" anchor="ctr"/>
+          <a:lstStyle/>
+          <a:p>
+            <a:pPr indent="0" marL="0">
+              <a:buNone/>
+            </a:pPr>
+            <a:r>
+              <a:rPr lang="en-US" sz="1500" dirty="0">
+                <a:solidFill>
+                  <a:schemeClr val="tx1"/>
+                </a:solidFill>
+                <a:latin typeface="+mj-lt" pitchFamily="34" charset="0"/>
+                <a:ea typeface="+mj-lt" pitchFamily="34" charset="-122"/>
+                <a:cs typeface="+mj-lt" pitchFamily="34" charset="-120"/>
+              </a:rPr>
+              <a:t>Ground truth</a:t>
+            </a:r>
+            <a:endParaRPr lang="en-US" sz="1500" dirty="0"/>
+          </a:p>
+        </p:txBody>
+      </p:sp>
+      <p:sp>
+        <p:nvSpPr>
+          <p:cNvPr id="18" name="Text 16"/>
+          <p:cNvSpPr txBox="1"/>
+          <p:nvPr/>
+        </p:nvSpPr>
+        <p:spPr>
+          <a:xfrm>
+            <a:off x="6415888" y="2075688"/>
             <a:ext cx="5227168" cy="292608"/>
           </a:xfrm>
           <a:prstGeom prst="rect">
@@ -14740,7 +14779,7 @@
                   </a:extLst>
                 </a:hlinkClick>
               </a:rPr>
-              <a:t>Irrigation Department: reservoir map layer</a:t>
+              <a:t>Irrigation Department: reservoir water level</a:t>
             </a:r>
             <a:pPr indent="0" marL="0">
               <a:buNone/>
@@ -14751,7 +14790,7 @@
                   <a:schemeClr val="accent6"/>
                 </a:solidFill>
               </a:rPr>
-              <a:t>  full supply levels</a:t>
+              <a:t>  the daily sheet</a:t>
             </a:r>
             <a:endParaRPr lang="en-US" sz="1250" dirty="0"/>
           </a:p>
@@ -14759,13 +14798,13 @@
       </p:sp>
       <p:sp>
         <p:nvSpPr>
-          <p:cNvPr id="18" name="Text 16"/>
-          <p:cNvSpPr txBox="1"/>
-          <p:nvPr/>
-        </p:nvSpPr>
-        <p:spPr>
-          <a:xfrm>
-            <a:off x="6415888" y="3008376"/>
+          <p:cNvPr id="19" name="Text 17"/>
+          <p:cNvSpPr txBox="1"/>
+          <p:nvPr/>
+        </p:nvSpPr>
+        <p:spPr>
+          <a:xfrm>
+            <a:off x="6415888" y="2386584"/>
             <a:ext cx="5227168" cy="292608"/>
           </a:xfrm>
           <a:prstGeom prst="rect">
@@ -14794,7 +14833,7 @@
                   </a:extLst>
                 </a:hlinkClick>
               </a:rPr>
-              <a:t>Kanhindawewa drone survey</a:t>
+              <a:t>Irrigation Department: reservoir status</a:t>
             </a:r>
             <a:pPr indent="0" marL="0">
               <a:buNone/>
@@ -14805,7 +14844,7 @@
                   <a:schemeClr val="accent6"/>
                 </a:solidFill>
               </a:rPr>
-              <a:t>  area and capacity every 1 ft (PDF)</a:t>
+              <a:t>  web page</a:t>
             </a:r>
             <a:endParaRPr lang="en-US" sz="1250" dirty="0"/>
           </a:p>
@@ -14813,13 +14852,13 @@
       </p:sp>
       <p:sp>
         <p:nvSpPr>
-          <p:cNvPr id="19" name="Text 17"/>
-          <p:cNvSpPr txBox="1"/>
-          <p:nvPr/>
-        </p:nvSpPr>
-        <p:spPr>
-          <a:xfrm>
-            <a:off x="6415888" y="3319272"/>
+          <p:cNvPr id="20" name="Text 18"/>
+          <p:cNvSpPr txBox="1"/>
+          <p:nvPr/>
+        </p:nvSpPr>
+        <p:spPr>
+          <a:xfrm>
+            <a:off x="6415888" y="2697480"/>
             <a:ext cx="5227168" cy="292608"/>
           </a:xfrm>
           <a:prstGeom prst="rect">
@@ -14848,7 +14887,7 @@
                   </a:extLst>
                 </a:hlinkClick>
               </a:rPr>
-              <a:t>Mahaweli Authority: reservoir status reports</a:t>
+              <a:t>Irrigation Department: reservoir map layer</a:t>
             </a:r>
             <a:pPr indent="0" marL="0">
               <a:buNone/>
@@ -14859,7 +14898,7 @@
                   <a:schemeClr val="accent6"/>
                 </a:solidFill>
               </a:rPr>
-              <a:t>  daily levels</a:t>
+              <a:t>  full supply levels</a:t>
             </a:r>
             <a:endParaRPr lang="en-US" sz="1250" dirty="0"/>
           </a:p>
@@ -14867,52 +14906,13 @@
       </p:sp>
       <p:sp>
         <p:nvSpPr>
-          <p:cNvPr id="20" name="Text 18"/>
-          <p:cNvSpPr txBox="1"/>
-          <p:nvPr/>
-        </p:nvSpPr>
-        <p:spPr>
-          <a:xfrm>
-            <a:off x="6278728" y="3776472"/>
-            <a:ext cx="5364328" cy="329184"/>
-          </a:xfrm>
-          <a:prstGeom prst="rect">
-            <a:avLst/>
-          </a:prstGeom>
-          <a:noFill/>
-          <a:ln/>
-        </p:spPr>
-        <p:txBody>
-          <a:bodyPr wrap="square" lIns="0" tIns="0" rIns="0" bIns="0" rtlCol="0" anchor="ctr"/>
-          <a:lstStyle/>
-          <a:p>
-            <a:pPr indent="0" marL="0">
-              <a:buNone/>
-            </a:pPr>
-            <a:r>
-              <a:rPr lang="en-US" sz="1500" dirty="0">
-                <a:solidFill>
-                  <a:schemeClr val="tx1"/>
-                </a:solidFill>
-                <a:latin typeface="+mj-lt" pitchFamily="34" charset="0"/>
-                <a:ea typeface="+mj-lt" pitchFamily="34" charset="-122"/>
-                <a:cs typeface="+mj-lt" pitchFamily="34" charset="-120"/>
-              </a:rPr>
-              <a:t>Weather (for the forecast)</a:t>
-            </a:r>
-            <a:endParaRPr lang="en-US" sz="1500" dirty="0"/>
-          </a:p>
-        </p:txBody>
-      </p:sp>
-      <p:sp>
-        <p:nvSpPr>
           <p:cNvPr id="21" name="Text 19"/>
           <p:cNvSpPr txBox="1"/>
           <p:nvPr/>
         </p:nvSpPr>
         <p:spPr>
           <a:xfrm>
-            <a:off x="6415888" y="4160520"/>
+            <a:off x="6415888" y="3008376"/>
             <a:ext cx="5227168" cy="292608"/>
           </a:xfrm>
           <a:prstGeom prst="rect">
@@ -14941,7 +14941,7 @@
                   </a:extLst>
                 </a:hlinkClick>
               </a:rPr>
-              <a:t>CHIRPS</a:t>
+              <a:t>Kanhindawewa drone survey</a:t>
             </a:r>
             <a:pPr indent="0" marL="0">
               <a:buNone/>
@@ -14952,7 +14952,7 @@
                   <a:schemeClr val="accent6"/>
                 </a:solidFill>
               </a:rPr>
-              <a:t>  daily rainfall</a:t>
+              <a:t>  area and capacity every 1 ft (PDF)</a:t>
             </a:r>
             <a:endParaRPr lang="en-US" sz="1250" dirty="0"/>
           </a:p>
@@ -14966,7 +14966,7 @@
         </p:nvSpPr>
         <p:spPr>
           <a:xfrm>
-            <a:off x="6415888" y="4471416"/>
+            <a:off x="6415888" y="3319272"/>
             <a:ext cx="5227168" cy="292608"/>
           </a:xfrm>
           <a:prstGeom prst="rect">
@@ -14995,7 +14995,7 @@
                   </a:extLst>
                 </a:hlinkClick>
               </a:rPr>
-              <a:t>ERA5</a:t>
+              <a:t>Mahaweli Authority: reservoir status reports</a:t>
             </a:r>
             <a:pPr indent="0" marL="0">
               <a:buNone/>
@@ -15006,7 +15006,7 @@
                   <a:schemeClr val="accent6"/>
                 </a:solidFill>
               </a:rPr>
-              <a:t>  weather, for evaporation</a:t>
+              <a:t>  daily levels</a:t>
             </a:r>
             <a:endParaRPr lang="en-US" sz="1250" dirty="0"/>
           </a:p>
@@ -15020,7 +15020,7 @@
         </p:nvSpPr>
         <p:spPr>
           <a:xfrm>
-            <a:off x="6278728" y="4928616"/>
+            <a:off x="6278728" y="3776472"/>
             <a:ext cx="5364328" cy="329184"/>
           </a:xfrm>
           <a:prstGeom prst="rect">
@@ -15045,6 +15045,207 @@
                 <a:ea typeface="+mj-lt" pitchFamily="34" charset="-122"/>
                 <a:cs typeface="+mj-lt" pitchFamily="34" charset="-120"/>
               </a:rPr>
+              <a:t>Weather (for the forecast)</a:t>
+            </a:r>
+            <a:endParaRPr lang="en-US" sz="1500" dirty="0"/>
+          </a:p>
+        </p:txBody>
+      </p:sp>
+      <p:sp>
+        <p:nvSpPr>
+          <p:cNvPr id="24" name="Text 22"/>
+          <p:cNvSpPr txBox="1"/>
+          <p:nvPr/>
+        </p:nvSpPr>
+        <p:spPr>
+          <a:xfrm>
+            <a:off x="6415888" y="4160520"/>
+            <a:ext cx="5227168" cy="292608"/>
+          </a:xfrm>
+          <a:prstGeom prst="rect">
+            <a:avLst/>
+          </a:prstGeom>
+          <a:noFill/>
+          <a:ln/>
+        </p:spPr>
+        <p:txBody>
+          <a:bodyPr wrap="square" lIns="0" tIns="0" rIns="0" bIns="0" rtlCol="0" anchor="ctr"/>
+          <a:lstStyle/>
+          <a:p>
+            <a:pPr indent="0" marL="0">
+              <a:buNone/>
+            </a:pPr>
+            <a:r>
+              <a:rPr lang="en-US" sz="1250" b="1" u="sng" dirty="0">
+                <a:solidFill>
+                  <a:schemeClr val="accent1"/>
+                </a:solidFill>
+                <a:hlinkClick r:id="rId16" invalidUrl="" action="" tgtFrame="" tooltip="" history="1" highlightClick="0" endSnd="0">
+                  <a:extLst>
+                    <a:ext uri="{A12FA001-AC4F-418D-AE19-62706E023703}">
+                      <ahyp:hlinkClr xmlns:ahyp="http://schemas.microsoft.com/office/drawing/2018/hyperlinkcolor" val="tx"/>
+                    </a:ext>
+                  </a:extLst>
+                </a:hlinkClick>
+              </a:rPr>
+              <a:t>GPM IMERG</a:t>
+            </a:r>
+            <a:pPr indent="0" marL="0">
+              <a:buNone/>
+            </a:pPr>
+            <a:r>
+              <a:rPr lang="en-US" sz="1250" dirty="0">
+                <a:solidFill>
+                  <a:schemeClr val="accent6"/>
+                </a:solidFill>
+              </a:rPr>
+              <a:t>  daily rainfall</a:t>
+            </a:r>
+            <a:endParaRPr lang="en-US" sz="1250" dirty="0"/>
+          </a:p>
+        </p:txBody>
+      </p:sp>
+      <p:sp>
+        <p:nvSpPr>
+          <p:cNvPr id="25" name="Text 23"/>
+          <p:cNvSpPr txBox="1"/>
+          <p:nvPr/>
+        </p:nvSpPr>
+        <p:spPr>
+          <a:xfrm>
+            <a:off x="6415888" y="4471416"/>
+            <a:ext cx="5227168" cy="292608"/>
+          </a:xfrm>
+          <a:prstGeom prst="rect">
+            <a:avLst/>
+          </a:prstGeom>
+          <a:noFill/>
+          <a:ln/>
+        </p:spPr>
+        <p:txBody>
+          <a:bodyPr wrap="square" lIns="0" tIns="0" rIns="0" bIns="0" rtlCol="0" anchor="ctr"/>
+          <a:lstStyle/>
+          <a:p>
+            <a:pPr indent="0" marL="0">
+              <a:buNone/>
+            </a:pPr>
+            <a:r>
+              <a:rPr lang="en-US" sz="1250" b="1" u="sng" dirty="0">
+                <a:solidFill>
+                  <a:schemeClr val="accent1"/>
+                </a:solidFill>
+                <a:hlinkClick r:id="rId17" invalidUrl="" action="" tgtFrame="" tooltip="" history="1" highlightClick="0" endSnd="0">
+                  <a:extLst>
+                    <a:ext uri="{A12FA001-AC4F-418D-AE19-62706E023703}">
+                      <ahyp:hlinkClr xmlns:ahyp="http://schemas.microsoft.com/office/drawing/2018/hyperlinkcolor" val="tx"/>
+                    </a:ext>
+                  </a:extLst>
+                </a:hlinkClick>
+              </a:rPr>
+              <a:t>CHIRPS</a:t>
+            </a:r>
+            <a:pPr indent="0" marL="0">
+              <a:buNone/>
+            </a:pPr>
+            <a:r>
+              <a:rPr lang="en-US" sz="1250" dirty="0">
+                <a:solidFill>
+                  <a:schemeClr val="accent6"/>
+                </a:solidFill>
+              </a:rPr>
+              <a:t>  monthly rainfall checks</a:t>
+            </a:r>
+            <a:endParaRPr lang="en-US" sz="1250" dirty="0"/>
+          </a:p>
+        </p:txBody>
+      </p:sp>
+      <p:sp>
+        <p:nvSpPr>
+          <p:cNvPr id="26" name="Text 24"/>
+          <p:cNvSpPr txBox="1"/>
+          <p:nvPr/>
+        </p:nvSpPr>
+        <p:spPr>
+          <a:xfrm>
+            <a:off x="6415888" y="4782312"/>
+            <a:ext cx="5227168" cy="292608"/>
+          </a:xfrm>
+          <a:prstGeom prst="rect">
+            <a:avLst/>
+          </a:prstGeom>
+          <a:noFill/>
+          <a:ln/>
+        </p:spPr>
+        <p:txBody>
+          <a:bodyPr wrap="square" lIns="0" tIns="0" rIns="0" bIns="0" rtlCol="0" anchor="ctr"/>
+          <a:lstStyle/>
+          <a:p>
+            <a:pPr indent="0" marL="0">
+              <a:buNone/>
+            </a:pPr>
+            <a:r>
+              <a:rPr lang="en-US" sz="1250" b="1" u="sng" dirty="0">
+                <a:solidFill>
+                  <a:schemeClr val="accent1"/>
+                </a:solidFill>
+                <a:hlinkClick r:id="rId18" invalidUrl="" action="" tgtFrame="" tooltip="" history="1" highlightClick="0" endSnd="0">
+                  <a:extLst>
+                    <a:ext uri="{A12FA001-AC4F-418D-AE19-62706E023703}">
+                      <ahyp:hlinkClr xmlns:ahyp="http://schemas.microsoft.com/office/drawing/2018/hyperlinkcolor" val="tx"/>
+                    </a:ext>
+                  </a:extLst>
+                </a:hlinkClick>
+              </a:rPr>
+              <a:t>ERA5</a:t>
+            </a:r>
+            <a:pPr indent="0" marL="0">
+              <a:buNone/>
+            </a:pPr>
+            <a:r>
+              <a:rPr lang="en-US" sz="1250" dirty="0">
+                <a:solidFill>
+                  <a:schemeClr val="accent6"/>
+                </a:solidFill>
+              </a:rPr>
+              <a:t>  weather, for evaporation</a:t>
+            </a:r>
+            <a:endParaRPr lang="en-US" sz="1250" dirty="0"/>
+          </a:p>
+        </p:txBody>
+      </p:sp>
+      <p:sp>
+        <p:nvSpPr>
+          <p:cNvPr id="27" name="Text 25"/>
+          <p:cNvSpPr txBox="1"/>
+          <p:nvPr/>
+        </p:nvSpPr>
+        <p:spPr>
+          <a:xfrm>
+            <a:off x="6278728" y="5239512"/>
+            <a:ext cx="5364328" cy="329184"/>
+          </a:xfrm>
+          <a:prstGeom prst="rect">
+            <a:avLst/>
+          </a:prstGeom>
+          <a:noFill/>
+          <a:ln/>
+        </p:spPr>
+        <p:txBody>
+          <a:bodyPr wrap="square" lIns="0" tIns="0" rIns="0" bIns="0" rtlCol="0" anchor="ctr"/>
+          <a:lstStyle/>
+          <a:p>
+            <a:pPr indent="0" marL="0">
+              <a:buNone/>
+            </a:pPr>
+            <a:r>
+              <a:rPr lang="en-US" sz="1500" dirty="0">
+                <a:solidFill>
+                  <a:schemeClr val="tx1"/>
+                </a:solidFill>
+                <a:latin typeface="+mj-lt" pitchFamily="34" charset="0"/>
+                <a:ea typeface="+mj-lt" pitchFamily="34" charset="-122"/>
+                <a:cs typeface="+mj-lt" pitchFamily="34" charset="-120"/>
+              </a:rPr>
               <a:t>Our work</a:t>
             </a:r>
             <a:endParaRPr lang="en-US" sz="1500" dirty="0"/>
@@ -15053,13 +15254,13 @@
       </p:sp>
       <p:sp>
         <p:nvSpPr>
-          <p:cNvPr id="24" name="Text 22"/>
-          <p:cNvSpPr txBox="1"/>
-          <p:nvPr/>
-        </p:nvSpPr>
-        <p:spPr>
-          <a:xfrm>
-            <a:off x="6415888" y="5312664"/>
+          <p:cNvPr id="28" name="Text 26"/>
+          <p:cNvSpPr txBox="1"/>
+          <p:nvPr/>
+        </p:nvSpPr>
+        <p:spPr>
+          <a:xfrm>
+            <a:off x="6415888" y="5623560"/>
             <a:ext cx="5227168" cy="292608"/>
           </a:xfrm>
           <a:prstGeom prst="rect">
@@ -15080,7 +15281,7 @@
                 <a:solidFill>
                   <a:schemeClr val="accent1"/>
                 </a:solidFill>
-                <a:hlinkClick r:id="rId16" invalidUrl="" action="" tgtFrame="" tooltip="" history="1" highlightClick="0" endSnd="0">
+                <a:hlinkClick r:id="rId19" invalidUrl="" action="" tgtFrame="" tooltip="" history="1" highlightClick="0" endSnd="0">
                   <a:extLst>
                     <a:ext uri="{A12FA001-AC4F-418D-AE19-62706E023703}">
                       <ahyp:hlinkClr xmlns:ahyp="http://schemas.microsoft.com/office/drawing/2018/hyperlinkcolor" val="tx"/>

</xml_diff>

<commit_message>
Presentation: slide 9 shows the whole chain (A, B, C)
</commit_message>
<xml_diff>
--- a/docs/presentation/swot-tank-tracker-proposal-talk.pptx
+++ b/docs/presentation/swot-tank-tracker-proposal-talk.pptx
@@ -127,7 +127,7 @@
   <p:extLst>
     <p:ext uri="{521415D9-36F7-43E2-AB2F-B90AF26B5E84}">
       <p14:sectionLst xmlns:p14="http://schemas.microsoft.com/office/powerpoint/2010/main">
-        <p14:section name="Introduction" id="{f81e3bdb-39ac-99b7-357a-9393e33d6931}">
+        <p14:section name="Introduction" id="{d88fc2d6-cbd3-4b55-58b7-55edff529e50}">
           <p14:sldIdLst>
             <p14:sldId id="256"/>
             <p14:sldId id="257"/>
@@ -135,28 +135,28 @@
             <p14:sldId id="259"/>
           </p14:sldIdLst>
         </p14:section>
-        <p14:section name="The satellites" id="{db251148-a154-e12f-6825-9dda8b65ed1c}">
+        <p14:section name="The satellites" id="{a4141ab3-8702-44c2-6181-ce1ae6fe5026}">
           <p14:sldIdLst>
             <p14:sldId id="260"/>
             <p14:sldId id="261"/>
             <p14:sldId id="262"/>
           </p14:sldIdLst>
         </p14:section>
-        <p14:section name="Study and method" id="{50a27b4f-4321-fbca-c55d-b142010bbaeb}">
+        <p14:section name="Study and method" id="{f9512384-1a5d-b312-ba0e-408d62a10b59}">
           <p14:sldIdLst>
             <p14:sldId id="263"/>
             <p14:sldId id="264"/>
             <p14:sldId id="265"/>
           </p14:sldIdLst>
         </p14:section>
-        <p14:section name="Evidence" id="{91b74a35-f3f0-bee9-cf86-363ee21ce51e}">
+        <p14:section name="Evidence" id="{6b4fb2f1-6436-aa0a-ec2f-fe4421ebd07e}">
           <p14:sldIdLst>
             <p14:sldId id="266"/>
             <p14:sldId id="267"/>
             <p14:sldId id="268"/>
           </p14:sldIdLst>
         </p14:section>
-        <p14:section name="Plan" id="{b7a470ed-8f5c-e574-ea44-a704798c720d}">
+        <p14:section name="Plan" id="{02f4f53c-d486-98d3-4d93-022511087548}">
           <p14:sldIdLst>
             <p14:sldId id="269"/>
             <p14:sldId id="270"/>
@@ -19915,18 +19915,54 @@
       </p:sp>
       <p:sp>
         <p:nvSpPr>
-          <p:cNvPr id="3" name="Sentinel inputs"/>
+          <p:cNvPr id="3" name="Text 1"/>
+          <p:cNvSpPr txBox="1"/>
+          <p:nvPr/>
+        </p:nvSpPr>
+        <p:spPr>
+          <a:xfrm>
+            <a:off x="548640" y="1143000"/>
+            <a:ext cx="11094415" cy="365760"/>
+          </a:xfrm>
+          <a:prstGeom prst="rect">
+            <a:avLst/>
+          </a:prstGeom>
+          <a:noFill/>
+          <a:ln/>
+        </p:spPr>
+        <p:txBody>
+          <a:bodyPr wrap="square" lIns="0" tIns="0" rIns="0" bIns="0" rtlCol="0" anchor="t"/>
+          <a:lstStyle/>
+          <a:p>
+            <a:pPr indent="0" marL="0">
+              <a:buNone/>
+            </a:pPr>
+            <a:r>
+              <a:rPr lang="en-US" sz="1400" dirty="0">
+                <a:solidFill>
+                  <a:schemeClr val="accent6"/>
+                </a:solidFill>
+              </a:rPr>
+              <a:t>Three models in one chain, one per member: A finds the water, B works out how full each tank is, and C looks ahead.</a:t>
+            </a:r>
+            <a:endParaRPr lang="en-US" sz="1400" dirty="0"/>
+          </a:p>
+        </p:txBody>
+      </p:sp>
+      <p:sp>
+        <p:nvSpPr>
+          <p:cNvPr id="4" name="Sentinel inputs"/>
           <p:cNvSpPr/>
           <p:nvPr/>
         </p:nvSpPr>
         <p:spPr>
           <a:xfrm>
-            <a:off x="548640" y="1371600"/>
-            <a:ext cx="2514600" cy="2514600"/>
+            <a:off x="548640" y="1691640"/>
+            <a:ext cx="2514600" cy="2103120"/>
           </a:xfrm>
           <a:prstGeom prst="roundRect">
             <a:avLst>
-              <a:gd name="adj" fmla="val 4364"/>
+              <a:gd name="adj" fmla="val 5217"/>
             </a:avLst>
           </a:prstGeom>
           <a:solidFill>
@@ -19942,13 +19978,13 @@
       </p:sp>
       <p:sp>
         <p:nvSpPr>
-          <p:cNvPr id="4" name="Text 2"/>
-          <p:cNvSpPr txBox="1"/>
-          <p:nvPr/>
-        </p:nvSpPr>
-        <p:spPr>
-          <a:xfrm>
-            <a:off x="731520" y="1508760"/>
+          <p:cNvPr id="5" name="Text 3"/>
+          <p:cNvSpPr txBox="1"/>
+          <p:nvPr/>
+        </p:nvSpPr>
+        <p:spPr>
+          <a:xfrm>
+            <a:off x="731520" y="1828800"/>
             <a:ext cx="2194560" cy="310896"/>
           </a:xfrm>
           <a:prstGeom prst="rect">
@@ -19981,13 +20017,13 @@
       </p:sp>
       <p:sp>
         <p:nvSpPr>
-          <p:cNvPr id="5" name="Text 3"/>
-          <p:cNvSpPr txBox="1"/>
-          <p:nvPr/>
-        </p:nvSpPr>
-        <p:spPr>
-          <a:xfrm>
-            <a:off x="731520" y="1828800"/>
+          <p:cNvPr id="6" name="Text 4"/>
+          <p:cNvSpPr txBox="1"/>
+          <p:nvPr/>
+        </p:nvSpPr>
+        <p:spPr>
+          <a:xfrm>
+            <a:off x="731520" y="2157984"/>
             <a:ext cx="2194560" cy="457200"/>
           </a:xfrm>
           <a:prstGeom prst="rect">
@@ -20017,7 +20053,7 @@
       </p:sp>
       <p:pic>
         <p:nvPicPr>
-          <p:cNvPr id="6" name="Image 0" descr="Sentinel-2 view of Hurulu Wewa">    </p:cNvPr>
+          <p:cNvPr id="7" name="Image 0" descr="Sentinel-2 view of Hurulu Wewa">    </p:cNvPr>
           <p:cNvPicPr>
             <a:picLocks noChangeAspect="1"/>
           </p:cNvPicPr>
@@ -20031,8 +20067,8 @@
         </p:blipFill>
         <p:spPr>
           <a:xfrm>
-            <a:off x="731520" y="2450592"/>
-            <a:ext cx="987552" cy="1042416"/>
+            <a:off x="731520" y="2679192"/>
+            <a:ext cx="932688" cy="987552"/>
           </a:xfrm>
           <a:prstGeom prst="rect">
             <a:avLst/>
@@ -20041,7 +20077,7 @@
       </p:pic>
       <p:pic>
         <p:nvPicPr>
-          <p:cNvPr id="7" name="Image 1" descr="Sentinel-1 radar view of Hurulu Wewa">    </p:cNvPr>
+          <p:cNvPr id="8" name="Image 1" descr="Sentinel-1 radar view of Hurulu Wewa">    </p:cNvPr>
           <p:cNvPicPr>
             <a:picLocks noChangeAspect="1"/>
           </p:cNvPicPr>
@@ -20055,8 +20091,8 @@
         </p:blipFill>
         <p:spPr>
           <a:xfrm>
-            <a:off x="1892808" y="2450592"/>
-            <a:ext cx="987552" cy="1042416"/>
+            <a:off x="1837944" y="2679192"/>
+            <a:ext cx="932688" cy="987552"/>
           </a:xfrm>
           <a:prstGeom prst="rect">
             <a:avLst/>
@@ -20065,14 +20101,14 @@
       </p:pic>
       <p:sp>
         <p:nvSpPr>
-          <p:cNvPr id="8" name="arrow"/>
+          <p:cNvPr id="9" name="arrow"/>
           <p:cNvSpPr/>
           <p:nvPr/>
         </p:nvSpPr>
         <p:spPr>
           <a:xfrm>
-            <a:off x="3063240" y="2628900"/>
-            <a:ext cx="548640" cy="0"/>
+            <a:off x="3063240" y="2743200"/>
+            <a:ext cx="457200" cy="0"/>
           </a:xfrm>
           <a:prstGeom prst="line">
             <a:avLst/>
@@ -20089,18 +20125,18 @@
       </p:sp>
       <p:sp>
         <p:nvSpPr>
-          <p:cNvPr id="9" name="AI water map"/>
+          <p:cNvPr id="10" name="AI water map"/>
           <p:cNvSpPr/>
           <p:nvPr/>
         </p:nvSpPr>
         <p:spPr>
           <a:xfrm>
-            <a:off x="3611880" y="1371600"/>
-            <a:ext cx="2514600" cy="2514600"/>
+            <a:off x="3520440" y="1691640"/>
+            <a:ext cx="2514600" cy="2103120"/>
           </a:xfrm>
           <a:prstGeom prst="roundRect">
             <a:avLst>
-              <a:gd name="adj" fmla="val 4364"/>
+              <a:gd name="adj" fmla="val 5217"/>
             </a:avLst>
           </a:prstGeom>
           <a:solidFill>
@@ -20116,37 +20152,82 @@
       </p:sp>
       <p:sp>
         <p:nvSpPr>
-          <p:cNvPr id="10" name="Text 6"/>
-          <p:cNvSpPr txBox="1"/>
-          <p:nvPr/>
-        </p:nvSpPr>
-        <p:spPr>
-          <a:xfrm>
-            <a:off x="3794760" y="1508760"/>
-            <a:ext cx="2194560" cy="310896"/>
-          </a:xfrm>
-          <a:prstGeom prst="rect">
-            <a:avLst/>
-          </a:prstGeom>
-          <a:noFill/>
-          <a:ln/>
-        </p:spPr>
-        <p:txBody>
-          <a:bodyPr wrap="square" lIns="0" tIns="0" rIns="0" bIns="0" rtlCol="0" anchor="t"/>
-          <a:lstStyle/>
-          <a:p>
-            <a:pPr indent="0" marL="0">
-              <a:buNone/>
-            </a:pPr>
-            <a:r>
-              <a:rPr lang="en-US" sz="1500" dirty="0">
-                <a:solidFill>
-                  <a:schemeClr val="tx1"/>
+          <p:cNvPr id="11" name="member A"/>
+          <p:cNvSpPr/>
+          <p:nvPr/>
+        </p:nvSpPr>
+        <p:spPr>
+          <a:xfrm>
+            <a:off x="3703320" y="1819656"/>
+            <a:ext cx="329184" cy="329184"/>
+          </a:xfrm>
+          <a:prstGeom prst="ellipse">
+            <a:avLst/>
+          </a:prstGeom>
+          <a:solidFill>
+            <a:schemeClr val="accent1"/>
+          </a:solidFill>
+          <a:ln>
+            <a:solidFill>
+              <a:schemeClr val="accent1"/>
+            </a:solidFill>
+          </a:ln>
+        </p:spPr>
+        <p:txBody>
+          <a:bodyPr wrap="square" lIns="0" tIns="0" rIns="0" bIns="0" rtlCol="0" anchor="ctr"/>
+          <a:lstStyle/>
+          <a:p>
+            <a:pPr algn="ctr" indent="0" marL="0">
+              <a:buNone/>
+            </a:pPr>
+            <a:r>
+              <a:rPr lang="en-US" sz="1300" b="1" dirty="0">
+                <a:solidFill>
+                  <a:schemeClr val="bg1"/>
                 </a:solidFill>
                 <a:latin typeface="+mj-lt" pitchFamily="34" charset="0"/>
                 <a:ea typeface="+mj-lt" pitchFamily="34" charset="-122"/>
                 <a:cs typeface="+mj-lt" pitchFamily="34" charset="-120"/>
               </a:rPr>
+              <a:t>A</a:t>
+            </a:r>
+            <a:endParaRPr lang="en-US" sz="1300" dirty="0"/>
+          </a:p>
+        </p:txBody>
+      </p:sp>
+      <p:sp>
+        <p:nvSpPr>
+          <p:cNvPr id="12" name="Text 8"/>
+          <p:cNvSpPr txBox="1"/>
+          <p:nvPr/>
+        </p:nvSpPr>
+        <p:spPr>
+          <a:xfrm>
+            <a:off x="4133088" y="1828800"/>
+            <a:ext cx="1764792" cy="310896"/>
+          </a:xfrm>
+          <a:prstGeom prst="rect">
+            <a:avLst/>
+          </a:prstGeom>
+          <a:noFill/>
+          <a:ln/>
+        </p:spPr>
+        <p:txBody>
+          <a:bodyPr wrap="square" lIns="0" tIns="0" rIns="0" bIns="0" rtlCol="0" anchor="t"/>
+          <a:lstStyle/>
+          <a:p>
+            <a:pPr indent="0" marL="0">
+              <a:buNone/>
+            </a:pPr>
+            <a:r>
+              <a:rPr lang="en-US" sz="1500" dirty="0">
+                <a:solidFill>
+                  <a:schemeClr val="tx1"/>
+                </a:solidFill>
+                <a:latin typeface="+mj-lt" pitchFamily="34" charset="0"/>
+                <a:ea typeface="+mj-lt" pitchFamily="34" charset="-122"/>
+                <a:cs typeface="+mj-lt" pitchFamily="34" charset="-120"/>
+              </a:rPr>
               <a:t>AI water map</a:t>
             </a:r>
             <a:endParaRPr lang="en-US" sz="1500" dirty="0"/>
@@ -20155,13 +20236,13 @@
       </p:sp>
       <p:sp>
         <p:nvSpPr>
-          <p:cNvPr id="11" name="Text 7"/>
-          <p:cNvSpPr txBox="1"/>
-          <p:nvPr/>
-        </p:nvSpPr>
-        <p:spPr>
-          <a:xfrm>
-            <a:off x="3794760" y="1828800"/>
+          <p:cNvPr id="13" name="Text 9"/>
+          <p:cNvSpPr txBox="1"/>
+          <p:nvPr/>
+        </p:nvSpPr>
+        <p:spPr>
+          <a:xfrm>
+            <a:off x="3703320" y="2157984"/>
             <a:ext cx="2194560" cy="457200"/>
           </a:xfrm>
           <a:prstGeom prst="rect">
@@ -20191,7 +20272,7 @@
       </p:sp>
       <p:pic>
         <p:nvPicPr>
-          <p:cNvPr id="12" name="Image 2" descr="Water map of Hurulu Wewa">    </p:cNvPr>
+          <p:cNvPr id="14" name="Image 2" descr="Water map of Hurulu Wewa">    </p:cNvPr>
           <p:cNvPicPr>
             <a:picLocks noChangeAspect="1"/>
           </p:cNvPicPr>
@@ -20205,8 +20286,8 @@
         </p:blipFill>
         <p:spPr>
           <a:xfrm>
-            <a:off x="4370832" y="2450592"/>
-            <a:ext cx="987552" cy="1042416"/>
+            <a:off x="4311396" y="2679192"/>
+            <a:ext cx="932688" cy="987552"/>
           </a:xfrm>
           <a:prstGeom prst="rect">
             <a:avLst/>
@@ -20215,18 +20296,18 @@
       </p:pic>
       <p:sp>
         <p:nvSpPr>
-          <p:cNvPr id="13" name="SWOT heights"/>
+          <p:cNvPr id="15" name="SWOT heights"/>
           <p:cNvSpPr/>
           <p:nvPr/>
         </p:nvSpPr>
         <p:spPr>
           <a:xfrm>
-            <a:off x="548640" y="4343400"/>
-            <a:ext cx="5577840" cy="1325880"/>
+            <a:off x="548640" y="4114800"/>
+            <a:ext cx="2514600" cy="1188720"/>
           </a:xfrm>
           <a:prstGeom prst="roundRect">
             <a:avLst>
-              <a:gd name="adj" fmla="val 8276"/>
+              <a:gd name="adj" fmla="val 9231"/>
             </a:avLst>
           </a:prstGeom>
           <a:solidFill>
@@ -20242,24 +20323,24 @@
       </p:sp>
       <p:sp>
         <p:nvSpPr>
-          <p:cNvPr id="14" name="icon FaSatellite"/>
+          <p:cNvPr id="16" name="icon FaSatellite"/>
           <p:cNvSpPr/>
           <p:nvPr/>
         </p:nvSpPr>
         <p:spPr>
           <a:xfrm>
-            <a:off x="822960" y="4718304"/>
-            <a:ext cx="566928" cy="566928"/>
+            <a:off x="731520" y="4457700"/>
+            <a:ext cx="502920" cy="502920"/>
           </a:xfrm>
           <a:prstGeom prst="ellipse">
             <a:avLst/>
           </a:prstGeom>
           <a:solidFill>
-            <a:schemeClr val="accent1"/>
+            <a:srgbClr val="12384D"/>
           </a:solidFill>
           <a:ln w="12700">
             <a:solidFill>
-              <a:schemeClr val="accent1"/>
+              <a:srgbClr val="12384D"/>
             </a:solidFill>
             <a:prstDash val="solid"/>
           </a:ln>
@@ -20267,7 +20348,7 @@
       </p:sp>
       <p:pic>
         <p:nvPicPr>
-          <p:cNvPr id="15" name="Image 3" descr="preencoded.png">    </p:cNvPr>
+          <p:cNvPr id="17" name="Image 3" descr="preencoded.png">    </p:cNvPr>
           <p:cNvPicPr>
             <a:picLocks noChangeAspect="1"/>
           </p:cNvPicPr>
@@ -20281,8 +20362,8 @@
         </p:blipFill>
         <p:spPr>
           <a:xfrm>
-            <a:off x="964692" y="4860036"/>
-            <a:ext cx="283464" cy="283464"/>
+            <a:off x="857250" y="4583430"/>
+            <a:ext cx="251460" cy="251460"/>
           </a:xfrm>
           <a:prstGeom prst="rect">
             <a:avLst/>
@@ -20291,14 +20372,14 @@
       </p:pic>
       <p:sp>
         <p:nvSpPr>
-          <p:cNvPr id="16" name="Text 10"/>
-          <p:cNvSpPr txBox="1"/>
-          <p:nvPr/>
-        </p:nvSpPr>
-        <p:spPr>
-          <a:xfrm>
-            <a:off x="1600200" y="4590288"/>
-            <a:ext cx="4297680" cy="329184"/>
+          <p:cNvPr id="18" name="Text 12"/>
+          <p:cNvSpPr txBox="1"/>
+          <p:nvPr/>
+        </p:nvSpPr>
+        <p:spPr>
+          <a:xfrm>
+            <a:off x="1417320" y="4261104"/>
+            <a:ext cx="1508760" cy="310896"/>
           </a:xfrm>
           <a:prstGeom prst="rect">
             <a:avLst/>
@@ -20322,7 +20403,7 @@
                 <a:ea typeface="+mj-lt" pitchFamily="34" charset="-122"/>
                 <a:cs typeface="+mj-lt" pitchFamily="34" charset="-120"/>
               </a:rPr>
-              <a:t>SWOT water heights</a:t>
+              <a:t>SWOT heights</a:t>
             </a:r>
             <a:endParaRPr lang="en-US" sz="1500" dirty="0"/>
           </a:p>
@@ -20330,14 +20411,14 @@
       </p:sp>
       <p:sp>
         <p:nvSpPr>
-          <p:cNvPr id="17" name="Text 11"/>
-          <p:cNvSpPr txBox="1"/>
-          <p:nvPr/>
-        </p:nvSpPr>
-        <p:spPr>
-          <a:xfrm>
-            <a:off x="1600200" y="4937760"/>
-            <a:ext cx="4343400" cy="548640"/>
+          <p:cNvPr id="19" name="Text 13"/>
+          <p:cNvSpPr txBox="1"/>
+          <p:nvPr/>
+        </p:nvSpPr>
+        <p:spPr>
+          <a:xfrm>
+            <a:off x="1417320" y="4590288"/>
+            <a:ext cx="1600200" cy="548640"/>
           </a:xfrm>
           <a:prstGeom prst="rect">
             <a:avLst/>
@@ -20358,22 +20439,36 @@
                   <a:schemeClr val="accent6"/>
                 </a:solidFill>
               </a:rPr>
-              <a:t>From NASA's Hydrocron service since July 2023, with poor readings removed</a:t>
+              <a:t>A height about twice</a:t>
             </a:r>
             <a:endParaRPr lang="en-US" sz="1150" dirty="0"/>
           </a:p>
-        </p:txBody>
-      </p:sp>
-      <p:sp>
-        <p:nvSpPr>
-          <p:cNvPr id="18" name="arrow"/>
+          <a:p>
+            <a:pPr indent="0" marL="0">
+              <a:buNone/>
+            </a:pPr>
+            <a:r>
+              <a:rPr lang="en-US" sz="1150" dirty="0">
+                <a:solidFill>
+                  <a:schemeClr val="accent6"/>
+                </a:solidFill>
+              </a:rPr>
+              <a:t>every 21 days</a:t>
+            </a:r>
+            <a:endParaRPr lang="en-US" sz="1150" dirty="0"/>
+          </a:p>
+        </p:txBody>
+      </p:sp>
+      <p:sp>
+        <p:nvSpPr>
+          <p:cNvPr id="20" name="arrow"/>
           <p:cNvSpPr/>
           <p:nvPr/>
         </p:nvSpPr>
         <p:spPr>
           <a:xfrm>
-            <a:off x="6126480" y="2628900"/>
-            <a:ext cx="548640" cy="388620"/>
+            <a:off x="3063240" y="4709160"/>
+            <a:ext cx="457200" cy="0"/>
           </a:xfrm>
           <a:prstGeom prst="line">
             <a:avLst/>
@@ -20390,14 +20485,161 @@
       </p:sp>
       <p:sp>
         <p:nvSpPr>
-          <p:cNvPr id="19" name="arrow"/>
+          <p:cNvPr id="21" name="Trust screen"/>
           <p:cNvSpPr/>
           <p:nvPr/>
         </p:nvSpPr>
         <p:spPr>
-          <a:xfrm flipV="1">
-            <a:off x="6126480" y="3931920"/>
-            <a:ext cx="548640" cy="1074420"/>
+          <a:xfrm>
+            <a:off x="3520440" y="4114800"/>
+            <a:ext cx="2514600" cy="1188720"/>
+          </a:xfrm>
+          <a:prstGeom prst="roundRect">
+            <a:avLst>
+              <a:gd name="adj" fmla="val 9231"/>
+            </a:avLst>
+          </a:prstGeom>
+          <a:solidFill>
+            <a:schemeClr val="bg2"/>
+          </a:solidFill>
+          <a:ln w="9525">
+            <a:solidFill>
+              <a:schemeClr val="bg2"/>
+            </a:solidFill>
+            <a:prstDash val="solid"/>
+          </a:ln>
+        </p:spPr>
+      </p:sp>
+      <p:sp>
+        <p:nvSpPr>
+          <p:cNvPr id="22" name="member B"/>
+          <p:cNvSpPr/>
+          <p:nvPr/>
+        </p:nvSpPr>
+        <p:spPr>
+          <a:xfrm>
+            <a:off x="3703320" y="4242816"/>
+            <a:ext cx="329184" cy="329184"/>
+          </a:xfrm>
+          <a:prstGeom prst="ellipse">
+            <a:avLst/>
+          </a:prstGeom>
+          <a:solidFill>
+            <a:schemeClr val="accent3"/>
+          </a:solidFill>
+          <a:ln>
+            <a:solidFill>
+              <a:schemeClr val="accent3"/>
+            </a:solidFill>
+          </a:ln>
+        </p:spPr>
+        <p:txBody>
+          <a:bodyPr wrap="square" lIns="0" tIns="0" rIns="0" bIns="0" rtlCol="0" anchor="ctr"/>
+          <a:lstStyle/>
+          <a:p>
+            <a:pPr algn="ctr" indent="0" marL="0">
+              <a:buNone/>
+            </a:pPr>
+            <a:r>
+              <a:rPr lang="en-US" sz="1300" b="1" dirty="0">
+                <a:solidFill>
+                  <a:schemeClr val="bg1"/>
+                </a:solidFill>
+                <a:latin typeface="+mj-lt" pitchFamily="34" charset="0"/>
+                <a:ea typeface="+mj-lt" pitchFamily="34" charset="-122"/>
+                <a:cs typeface="+mj-lt" pitchFamily="34" charset="-120"/>
+              </a:rPr>
+              <a:t>B</a:t>
+            </a:r>
+            <a:endParaRPr lang="en-US" sz="1300" dirty="0"/>
+          </a:p>
+        </p:txBody>
+      </p:sp>
+      <p:sp>
+        <p:nvSpPr>
+          <p:cNvPr id="23" name="Text 17"/>
+          <p:cNvSpPr txBox="1"/>
+          <p:nvPr/>
+        </p:nvSpPr>
+        <p:spPr>
+          <a:xfrm>
+            <a:off x="4133088" y="4251960"/>
+            <a:ext cx="1764792" cy="310896"/>
+          </a:xfrm>
+          <a:prstGeom prst="rect">
+            <a:avLst/>
+          </a:prstGeom>
+          <a:noFill/>
+          <a:ln/>
+        </p:spPr>
+        <p:txBody>
+          <a:bodyPr wrap="square" lIns="0" tIns="0" rIns="0" bIns="0" rtlCol="0" anchor="t"/>
+          <a:lstStyle/>
+          <a:p>
+            <a:pPr indent="0" marL="0">
+              <a:buNone/>
+            </a:pPr>
+            <a:r>
+              <a:rPr lang="en-US" sz="1500" dirty="0">
+                <a:solidFill>
+                  <a:schemeClr val="tx1"/>
+                </a:solidFill>
+                <a:latin typeface="+mj-lt" pitchFamily="34" charset="0"/>
+                <a:ea typeface="+mj-lt" pitchFamily="34" charset="-122"/>
+                <a:cs typeface="+mj-lt" pitchFamily="34" charset="-120"/>
+              </a:rPr>
+              <a:t>Trust screen</a:t>
+            </a:r>
+            <a:endParaRPr lang="en-US" sz="1500" dirty="0"/>
+          </a:p>
+        </p:txBody>
+      </p:sp>
+      <p:sp>
+        <p:nvSpPr>
+          <p:cNvPr id="24" name="Text 18"/>
+          <p:cNvSpPr txBox="1"/>
+          <p:nvPr/>
+        </p:nvSpPr>
+        <p:spPr>
+          <a:xfrm>
+            <a:off x="3703320" y="4608576"/>
+            <a:ext cx="2194560" cy="548640"/>
+          </a:xfrm>
+          <a:prstGeom prst="rect">
+            <a:avLst/>
+          </a:prstGeom>
+          <a:noFill/>
+          <a:ln/>
+        </p:spPr>
+        <p:txBody>
+          <a:bodyPr wrap="square" lIns="0" tIns="0" rIns="0" bIns="0" rtlCol="0" anchor="t"/>
+          <a:lstStyle/>
+          <a:p>
+            <a:pPr indent="0" marL="0">
+              <a:buNone/>
+            </a:pPr>
+            <a:r>
+              <a:rPr lang="en-US" sz="1150" dirty="0">
+                <a:solidFill>
+                  <a:schemeClr val="accent6"/>
+                </a:solidFill>
+              </a:rPr>
+              <a:t>Keeps the good “suspect” readings and drops the bad ones</a:t>
+            </a:r>
+            <a:endParaRPr lang="en-US" sz="1150" dirty="0"/>
+          </a:p>
+        </p:txBody>
+      </p:sp>
+      <p:sp>
+        <p:nvSpPr>
+          <p:cNvPr id="25" name="arrow"/>
+          <p:cNvSpPr/>
+          <p:nvPr/>
+        </p:nvSpPr>
+        <p:spPr>
+          <a:xfrm>
+            <a:off x="6035040" y="2743200"/>
+            <a:ext cx="457200" cy="0"/>
           </a:xfrm>
           <a:prstGeom prst="line">
             <a:avLst/>
@@ -20414,18 +20656,42 @@
       </p:sp>
       <p:sp>
         <p:nvSpPr>
-          <p:cNvPr id="20" name="Height-area-volume curve"/>
+          <p:cNvPr id="26" name="arrow"/>
           <p:cNvSpPr/>
           <p:nvPr/>
         </p:nvSpPr>
         <p:spPr>
           <a:xfrm>
-            <a:off x="6675120" y="2331720"/>
-            <a:ext cx="2423160" cy="2011680"/>
+            <a:off x="6035040" y="4709160"/>
+            <a:ext cx="457200" cy="0"/>
+          </a:xfrm>
+          <a:prstGeom prst="line">
+            <a:avLst/>
+          </a:prstGeom>
+          <a:noFill/>
+          <a:ln w="22225">
+            <a:solidFill>
+              <a:srgbClr val="56656F"/>
+            </a:solidFill>
+            <a:prstDash val="solid"/>
+            <a:tailEnd type="triangle"/>
+          </a:ln>
+        </p:spPr>
+      </p:sp>
+      <p:sp>
+        <p:nvSpPr>
+          <p:cNvPr id="27" name="Storage model"/>
+          <p:cNvSpPr/>
+          <p:nvPr/>
+        </p:nvSpPr>
+        <p:spPr>
+          <a:xfrm>
+            <a:off x="6492240" y="2286000"/>
+            <a:ext cx="2468880" cy="2743200"/>
           </a:xfrm>
           <a:prstGeom prst="roundRect">
             <a:avLst>
-              <a:gd name="adj" fmla="val 5455"/>
+              <a:gd name="adj" fmla="val 4444"/>
             </a:avLst>
           </a:prstGeom>
           <a:solidFill>
@@ -20441,30 +20707,36 @@
       </p:sp>
       <p:sp>
         <p:nvSpPr>
-          <p:cNvPr id="21" name="Text 15"/>
-          <p:cNvSpPr txBox="1"/>
-          <p:nvPr/>
-        </p:nvSpPr>
-        <p:spPr>
-          <a:xfrm>
-            <a:off x="6858000" y="2487168"/>
-            <a:ext cx="2103120" cy="640080"/>
-          </a:xfrm>
-          <a:prstGeom prst="rect">
-            <a:avLst/>
-          </a:prstGeom>
-          <a:noFill/>
-          <a:ln/>
-        </p:spPr>
-        <p:txBody>
-          <a:bodyPr wrap="square" lIns="0" tIns="0" rIns="0" bIns="0" rtlCol="0" anchor="t"/>
-          <a:lstStyle/>
-          <a:p>
-            <a:pPr indent="0" marL="0">
-              <a:buNone/>
-            </a:pPr>
-            <a:r>
-              <a:rPr lang="en-US" sz="1600" dirty="0">
+          <p:cNvPr id="28" name="member B"/>
+          <p:cNvSpPr/>
+          <p:nvPr/>
+        </p:nvSpPr>
+        <p:spPr>
+          <a:xfrm>
+            <a:off x="6675120" y="2450592"/>
+            <a:ext cx="329184" cy="329184"/>
+          </a:xfrm>
+          <a:prstGeom prst="ellipse">
+            <a:avLst/>
+          </a:prstGeom>
+          <a:solidFill>
+            <a:schemeClr val="accent3"/>
+          </a:solidFill>
+          <a:ln>
+            <a:solidFill>
+              <a:schemeClr val="accent3"/>
+            </a:solidFill>
+          </a:ln>
+        </p:spPr>
+        <p:txBody>
+          <a:bodyPr wrap="square" lIns="0" tIns="0" rIns="0" bIns="0" rtlCol="0" anchor="ctr"/>
+          <a:lstStyle/>
+          <a:p>
+            <a:pPr algn="ctr" indent="0" marL="0">
+              <a:buNone/>
+            </a:pPr>
+            <a:r>
+              <a:rPr lang="en-US" sz="1300" b="1" dirty="0">
                 <a:solidFill>
                   <a:schemeClr val="bg1"/>
                 </a:solidFill>
@@ -20472,7 +20744,46 @@
                 <a:ea typeface="+mj-lt" pitchFamily="34" charset="-122"/>
                 <a:cs typeface="+mj-lt" pitchFamily="34" charset="-120"/>
               </a:rPr>
-              <a:t>Height–area–volume curve</a:t>
+              <a:t>B</a:t>
+            </a:r>
+            <a:endParaRPr lang="en-US" sz="1300" dirty="0"/>
+          </a:p>
+        </p:txBody>
+      </p:sp>
+      <p:sp>
+        <p:nvSpPr>
+          <p:cNvPr id="29" name="Text 23"/>
+          <p:cNvSpPr txBox="1"/>
+          <p:nvPr/>
+        </p:nvSpPr>
+        <p:spPr>
+          <a:xfrm>
+            <a:off x="7104888" y="2459736"/>
+            <a:ext cx="1737360" cy="329184"/>
+          </a:xfrm>
+          <a:prstGeom prst="rect">
+            <a:avLst/>
+          </a:prstGeom>
+          <a:noFill/>
+          <a:ln/>
+        </p:spPr>
+        <p:txBody>
+          <a:bodyPr wrap="square" lIns="0" tIns="0" rIns="0" bIns="0" rtlCol="0" anchor="t"/>
+          <a:lstStyle/>
+          <a:p>
+            <a:pPr indent="0" marL="0">
+              <a:buNone/>
+            </a:pPr>
+            <a:r>
+              <a:rPr lang="en-US" sz="1600" dirty="0">
+                <a:solidFill>
+                  <a:schemeClr val="bg1"/>
+                </a:solidFill>
+                <a:latin typeface="+mj-lt" pitchFamily="34" charset="0"/>
+                <a:ea typeface="+mj-lt" pitchFamily="34" charset="-122"/>
+                <a:cs typeface="+mj-lt" pitchFamily="34" charset="-120"/>
+              </a:rPr>
+              <a:t>Storage model</a:t>
             </a:r>
             <a:endParaRPr lang="en-US" sz="1600" dirty="0"/>
           </a:p>
@@ -20480,14 +20791,14 @@
       </p:sp>
       <p:sp>
         <p:nvSpPr>
-          <p:cNvPr id="22" name="Text 16"/>
-          <p:cNvSpPr txBox="1"/>
-          <p:nvPr/>
-        </p:nvSpPr>
-        <p:spPr>
-          <a:xfrm>
-            <a:off x="6858000" y="3200400"/>
-            <a:ext cx="2103120" cy="1005840"/>
+          <p:cNvPr id="30" name="Text 24"/>
+          <p:cNvSpPr txBox="1"/>
+          <p:nvPr/>
+        </p:nvSpPr>
+        <p:spPr>
+          <a:xfrm>
+            <a:off x="6675120" y="3017520"/>
+            <a:ext cx="2103120" cy="822960"/>
           </a:xfrm>
           <a:prstGeom prst="rect">
             <a:avLst/>
@@ -20503,12 +20814,65 @@
               <a:buNone/>
             </a:pPr>
             <a:r>
+              <a:rPr lang="en-US" sz="1300" dirty="0">
+                <a:solidFill>
+                  <a:srgbClr val="C9D6DE"/>
+                </a:solidFill>
+              </a:rPr>
+              <a:t>height + water area</a:t>
+            </a:r>
+            <a:endParaRPr lang="en-US" sz="1500" dirty="0"/>
+          </a:p>
+          <a:p>
+            <a:pPr indent="0" marL="0">
+              <a:buNone/>
+            </a:pPr>
+            <a:r>
+              <a:rPr lang="en-US" sz="2200" dirty="0">
+                <a:solidFill>
+                  <a:schemeClr val="bg1"/>
+                </a:solidFill>
+                <a:latin typeface="+mj-lt" pitchFamily="34" charset="0"/>
+                <a:ea typeface="+mj-lt" pitchFamily="34" charset="-122"/>
+                <a:cs typeface="+mj-lt" pitchFamily="34" charset="-120"/>
+              </a:rPr>
+              <a:t>→ % full</a:t>
+            </a:r>
+            <a:endParaRPr lang="en-US" sz="1500" dirty="0"/>
+          </a:p>
+        </p:txBody>
+      </p:sp>
+      <p:sp>
+        <p:nvSpPr>
+          <p:cNvPr id="31" name="Text 25"/>
+          <p:cNvSpPr txBox="1"/>
+          <p:nvPr/>
+        </p:nvSpPr>
+        <p:spPr>
+          <a:xfrm>
+            <a:off x="6675120" y="3977640"/>
+            <a:ext cx="2103120" cy="868680"/>
+          </a:xfrm>
+          <a:prstGeom prst="rect">
+            <a:avLst/>
+          </a:prstGeom>
+          <a:noFill/>
+          <a:ln/>
+        </p:spPr>
+        <p:txBody>
+          <a:bodyPr wrap="square" lIns="0" tIns="0" rIns="0" bIns="0" rtlCol="0" anchor="t"/>
+          <a:lstStyle/>
+          <a:p>
+            <a:pPr indent="0" marL="0">
+              <a:buNone/>
+            </a:pPr>
+            <a:r>
               <a:rPr lang="en-US" sz="1150" dirty="0">
                 <a:solidFill>
                   <a:srgbClr val="C9D6DE"/>
                 </a:solidFill>
               </a:rPr>
-              <a:t>One per tank: each SWOT height paired with the AI water area of the same day</a:t>
+              <a:t>Trained on about 100 gauged reservoirs, so it also works for tanks with no records</a:t>
             </a:r>
             <a:endParaRPr lang="en-US" sz="1150" dirty="0"/>
           </a:p>
@@ -20516,14 +20880,14 @@
       </p:sp>
       <p:sp>
         <p:nvSpPr>
-          <p:cNvPr id="23" name="arrow"/>
+          <p:cNvPr id="32" name="arrow"/>
           <p:cNvSpPr/>
           <p:nvPr/>
         </p:nvSpPr>
         <p:spPr>
           <a:xfrm>
-            <a:off x="9098280" y="3337560"/>
-            <a:ext cx="411480" cy="0"/>
+            <a:off x="8961120" y="2743200"/>
+            <a:ext cx="457200" cy="0"/>
           </a:xfrm>
           <a:prstGeom prst="line">
             <a:avLst/>
@@ -20540,18 +20904,18 @@
       </p:sp>
       <p:sp>
         <p:nvSpPr>
-          <p:cNvPr id="24" name="Storage"/>
+          <p:cNvPr id="33" name="Storage"/>
           <p:cNvSpPr/>
           <p:nvPr/>
         </p:nvSpPr>
         <p:spPr>
           <a:xfrm>
-            <a:off x="9509760" y="2331720"/>
-            <a:ext cx="2130552" cy="2011680"/>
+            <a:off x="9418320" y="1691640"/>
+            <a:ext cx="2224735" cy="1783080"/>
           </a:xfrm>
           <a:prstGeom prst="roundRect">
             <a:avLst>
-              <a:gd name="adj" fmla="val 5455"/>
+              <a:gd name="adj" fmla="val 6154"/>
             </a:avLst>
           </a:prstGeom>
           <a:solidFill>
@@ -20567,14 +20931,14 @@
       </p:sp>
       <p:sp>
         <p:nvSpPr>
-          <p:cNvPr id="25" name="Text 19"/>
-          <p:cNvSpPr txBox="1"/>
-          <p:nvPr/>
-        </p:nvSpPr>
-        <p:spPr>
-          <a:xfrm>
-            <a:off x="9674352" y="2487168"/>
-            <a:ext cx="1828800" cy="640080"/>
+          <p:cNvPr id="34" name="Text 28"/>
+          <p:cNvSpPr txBox="1"/>
+          <p:nvPr/>
+        </p:nvSpPr>
+        <p:spPr>
+          <a:xfrm>
+            <a:off x="9601200" y="1828800"/>
+            <a:ext cx="1874520" cy="640080"/>
           </a:xfrm>
           <a:prstGeom prst="rect">
             <a:avLst/>
@@ -20623,14 +20987,14 @@
       </p:sp>
       <p:sp>
         <p:nvSpPr>
-          <p:cNvPr id="26" name="Text 20"/>
-          <p:cNvSpPr txBox="1"/>
-          <p:nvPr/>
-        </p:nvSpPr>
-        <p:spPr>
-          <a:xfrm>
-            <a:off x="9674352" y="3200400"/>
-            <a:ext cx="1828800" cy="1005840"/>
+          <p:cNvPr id="35" name="Text 29"/>
+          <p:cNvSpPr txBox="1"/>
+          <p:nvPr/>
+        </p:nvSpPr>
+        <p:spPr>
+          <a:xfrm>
+            <a:off x="9601200" y="2560320"/>
+            <a:ext cx="1920240" cy="777240"/>
           </a:xfrm>
           <a:prstGeom prst="rect">
             <a:avLst/>
@@ -20651,22 +21015,50 @@
                   <a:schemeClr val="accent6"/>
                 </a:solidFill>
               </a:rPr>
-              <a:t>Each new water map becomes a volume, shown on a dashboard</a:t>
+              <a:t>% full for every tank,</a:t>
             </a:r>
             <a:endParaRPr lang="en-US" sz="1150" dirty="0"/>
           </a:p>
-        </p:txBody>
-      </p:sp>
-      <p:sp>
-        <p:nvSpPr>
-          <p:cNvPr id="27" name="arrow"/>
+          <a:p>
+            <a:pPr indent="0" marL="0">
+              <a:buNone/>
+            </a:pPr>
+            <a:r>
+              <a:rPr lang="en-US" sz="1150" dirty="0">
+                <a:solidFill>
+                  <a:schemeClr val="accent6"/>
+                </a:solidFill>
+              </a:rPr>
+              <a:t>after each new picture</a:t>
+            </a:r>
+            <a:endParaRPr lang="en-US" sz="1150" dirty="0"/>
+          </a:p>
+          <a:p>
+            <a:pPr indent="0" marL="0">
+              <a:buNone/>
+            </a:pPr>
+            <a:r>
+              <a:rPr lang="en-US" sz="1150" dirty="0">
+                <a:solidFill>
+                  <a:schemeClr val="accent6"/>
+                </a:solidFill>
+              </a:rPr>
+              <a:t>or SWOT pass</a:t>
+            </a:r>
+            <a:endParaRPr lang="en-US" sz="1150" dirty="0"/>
+          </a:p>
+        </p:txBody>
+      </p:sp>
+      <p:sp>
+        <p:nvSpPr>
+          <p:cNvPr id="36" name="arrow"/>
           <p:cNvSpPr/>
           <p:nvPr/>
         </p:nvSpPr>
         <p:spPr>
           <a:xfrm>
-            <a:off x="10575036" y="4343400"/>
-            <a:ext cx="0" cy="365760"/>
+            <a:off x="10530688" y="3474720"/>
+            <a:ext cx="0" cy="320040"/>
           </a:xfrm>
           <a:prstGeom prst="line">
             <a:avLst/>
@@ -20683,18 +21075,241 @@
       </p:sp>
       <p:sp>
         <p:nvSpPr>
-          <p:cNvPr id="28" name="Validation"/>
+          <p:cNvPr id="37" name="Forecast"/>
           <p:cNvSpPr/>
           <p:nvPr/>
         </p:nvSpPr>
         <p:spPr>
           <a:xfrm>
-            <a:off x="6675120" y="4709160"/>
-            <a:ext cx="4965192" cy="960120"/>
+            <a:off x="9418320" y="3794760"/>
+            <a:ext cx="2224735" cy="1508760"/>
           </a:xfrm>
           <a:prstGeom prst="roundRect">
             <a:avLst>
-              <a:gd name="adj" fmla="val 11429"/>
+              <a:gd name="adj" fmla="val 7273"/>
+            </a:avLst>
+          </a:prstGeom>
+          <a:solidFill>
+            <a:schemeClr val="bg2"/>
+          </a:solidFill>
+          <a:ln w="9525">
+            <a:solidFill>
+              <a:schemeClr val="bg2"/>
+            </a:solidFill>
+            <a:prstDash val="solid"/>
+          </a:ln>
+        </p:spPr>
+      </p:sp>
+      <p:sp>
+        <p:nvSpPr>
+          <p:cNvPr id="38" name="member C"/>
+          <p:cNvSpPr/>
+          <p:nvPr/>
+        </p:nvSpPr>
+        <p:spPr>
+          <a:xfrm>
+            <a:off x="9601200" y="3922776"/>
+            <a:ext cx="329184" cy="329184"/>
+          </a:xfrm>
+          <a:prstGeom prst="ellipse">
+            <a:avLst/>
+          </a:prstGeom>
+          <a:solidFill>
+            <a:schemeClr val="accent2"/>
+          </a:solidFill>
+          <a:ln>
+            <a:solidFill>
+              <a:schemeClr val="accent2"/>
+            </a:solidFill>
+          </a:ln>
+        </p:spPr>
+        <p:txBody>
+          <a:bodyPr wrap="square" lIns="0" tIns="0" rIns="0" bIns="0" rtlCol="0" anchor="ctr"/>
+          <a:lstStyle/>
+          <a:p>
+            <a:pPr algn="ctr" indent="0" marL="0">
+              <a:buNone/>
+            </a:pPr>
+            <a:r>
+              <a:rPr lang="en-US" sz="1300" b="1" dirty="0">
+                <a:solidFill>
+                  <a:schemeClr val="bg1"/>
+                </a:solidFill>
+                <a:latin typeface="+mj-lt" pitchFamily="34" charset="0"/>
+                <a:ea typeface="+mj-lt" pitchFamily="34" charset="-122"/>
+                <a:cs typeface="+mj-lt" pitchFamily="34" charset="-120"/>
+              </a:rPr>
+              <a:t>C</a:t>
+            </a:r>
+            <a:endParaRPr lang="en-US" sz="1300" dirty="0"/>
+          </a:p>
+        </p:txBody>
+      </p:sp>
+      <p:sp>
+        <p:nvSpPr>
+          <p:cNvPr id="39" name="Text 33"/>
+          <p:cNvSpPr txBox="1"/>
+          <p:nvPr/>
+        </p:nvSpPr>
+        <p:spPr>
+          <a:xfrm>
+            <a:off x="10030968" y="3931920"/>
+            <a:ext cx="1463040" cy="310896"/>
+          </a:xfrm>
+          <a:prstGeom prst="rect">
+            <a:avLst/>
+          </a:prstGeom>
+          <a:noFill/>
+          <a:ln/>
+        </p:spPr>
+        <p:txBody>
+          <a:bodyPr wrap="square" lIns="0" tIns="0" rIns="0" bIns="0" rtlCol="0" anchor="t"/>
+          <a:lstStyle/>
+          <a:p>
+            <a:pPr indent="0" marL="0">
+              <a:buNone/>
+            </a:pPr>
+            <a:r>
+              <a:rPr lang="en-US" sz="1500" dirty="0">
+                <a:solidFill>
+                  <a:schemeClr val="tx1"/>
+                </a:solidFill>
+                <a:latin typeface="+mj-lt" pitchFamily="34" charset="0"/>
+                <a:ea typeface="+mj-lt" pitchFamily="34" charset="-122"/>
+                <a:cs typeface="+mj-lt" pitchFamily="34" charset="-120"/>
+              </a:rPr>
+              <a:t>Forecast</a:t>
+            </a:r>
+            <a:endParaRPr lang="en-US" sz="1500" dirty="0"/>
+          </a:p>
+        </p:txBody>
+      </p:sp>
+      <p:sp>
+        <p:nvSpPr>
+          <p:cNvPr id="40" name="Text 34"/>
+          <p:cNvSpPr txBox="1"/>
+          <p:nvPr/>
+        </p:nvSpPr>
+        <p:spPr>
+          <a:xfrm>
+            <a:off x="9601200" y="4315968"/>
+            <a:ext cx="1920240" cy="868680"/>
+          </a:xfrm>
+          <a:prstGeom prst="rect">
+            <a:avLst/>
+          </a:prstGeom>
+          <a:noFill/>
+          <a:ln/>
+        </p:spPr>
+        <p:txBody>
+          <a:bodyPr wrap="square" lIns="0" tIns="0" rIns="0" bIns="0" rtlCol="0" anchor="t"/>
+          <a:lstStyle/>
+          <a:p>
+            <a:pPr indent="0" marL="0">
+              <a:buNone/>
+            </a:pPr>
+            <a:r>
+              <a:rPr lang="en-US" sz="1150" dirty="0">
+                <a:solidFill>
+                  <a:schemeClr val="accent6"/>
+                </a:solidFill>
+              </a:rPr>
+              <a:t>2–4 weeks ahead, from</a:t>
+            </a:r>
+            <a:endParaRPr lang="en-US" sz="1150" dirty="0"/>
+          </a:p>
+          <a:p>
+            <a:pPr indent="0" marL="0">
+              <a:buNone/>
+            </a:pPr>
+            <a:r>
+              <a:rPr lang="en-US" sz="1150" dirty="0">
+                <a:solidFill>
+                  <a:schemeClr val="accent6"/>
+                </a:solidFill>
+              </a:rPr>
+              <a:t>rain and evaporation,</a:t>
+            </a:r>
+            <a:endParaRPr lang="en-US" sz="1150" dirty="0"/>
+          </a:p>
+          <a:p>
+            <a:pPr indent="0" marL="0">
+              <a:buNone/>
+            </a:pPr>
+            <a:r>
+              <a:rPr lang="en-US" sz="1150" dirty="0">
+                <a:solidFill>
+                  <a:schemeClr val="accent6"/>
+                </a:solidFill>
+              </a:rPr>
+              <a:t>shown on a dashboard</a:t>
+            </a:r>
+            <a:endParaRPr lang="en-US" sz="1150" dirty="0"/>
+          </a:p>
+        </p:txBody>
+      </p:sp>
+      <p:sp>
+        <p:nvSpPr>
+          <p:cNvPr id="41" name="arrow"/>
+          <p:cNvSpPr/>
+          <p:nvPr/>
+        </p:nvSpPr>
+        <p:spPr>
+          <a:xfrm>
+            <a:off x="7726680" y="5029200"/>
+            <a:ext cx="0" cy="548640"/>
+          </a:xfrm>
+          <a:prstGeom prst="line">
+            <a:avLst/>
+          </a:prstGeom>
+          <a:noFill/>
+          <a:ln w="22225">
+            <a:solidFill>
+              <a:srgbClr val="56656F"/>
+            </a:solidFill>
+            <a:prstDash val="solid"/>
+            <a:tailEnd type="triangle"/>
+          </a:ln>
+        </p:spPr>
+      </p:sp>
+      <p:sp>
+        <p:nvSpPr>
+          <p:cNvPr id="42" name="arrow"/>
+          <p:cNvSpPr/>
+          <p:nvPr/>
+        </p:nvSpPr>
+        <p:spPr>
+          <a:xfrm>
+            <a:off x="10530688" y="5303520"/>
+            <a:ext cx="0" cy="274320"/>
+          </a:xfrm>
+          <a:prstGeom prst="line">
+            <a:avLst/>
+          </a:prstGeom>
+          <a:noFill/>
+          <a:ln w="22225">
+            <a:solidFill>
+              <a:srgbClr val="56656F"/>
+            </a:solidFill>
+            <a:prstDash val="solid"/>
+            <a:tailEnd type="triangle"/>
+          </a:ln>
+        </p:spPr>
+      </p:sp>
+      <p:sp>
+        <p:nvSpPr>
+          <p:cNvPr id="43" name="Validation"/>
+          <p:cNvSpPr/>
+          <p:nvPr/>
+        </p:nvSpPr>
+        <p:spPr>
+          <a:xfrm>
+            <a:off x="548640" y="5577840"/>
+            <a:ext cx="11094415" cy="685800"/>
+          </a:xfrm>
+          <a:prstGeom prst="roundRect">
+            <a:avLst>
+              <a:gd name="adj" fmla="val 16000"/>
             </a:avLst>
           </a:prstGeom>
           <a:solidFill>
@@ -20710,24 +21325,24 @@
       </p:sp>
       <p:sp>
         <p:nvSpPr>
-          <p:cNvPr id="29" name="icon FaCheck"/>
+          <p:cNvPr id="44" name="icon FaCheck"/>
           <p:cNvSpPr/>
           <p:nvPr/>
         </p:nvSpPr>
         <p:spPr>
           <a:xfrm>
-            <a:off x="6858000" y="4928616"/>
-            <a:ext cx="512064" cy="512064"/>
+            <a:off x="731520" y="5669280"/>
+            <a:ext cx="502920" cy="502920"/>
           </a:xfrm>
           <a:prstGeom prst="ellipse">
             <a:avLst/>
           </a:prstGeom>
           <a:solidFill>
-            <a:schemeClr val="accent3"/>
+            <a:srgbClr val="12384D"/>
           </a:solidFill>
           <a:ln w="12700">
             <a:solidFill>
-              <a:schemeClr val="accent3"/>
+              <a:srgbClr val="12384D"/>
             </a:solidFill>
             <a:prstDash val="solid"/>
           </a:ln>
@@ -20735,7 +21350,7 @@
       </p:sp>
       <p:pic>
         <p:nvPicPr>
-          <p:cNvPr id="30" name="Image 4" descr="preencoded.png">    </p:cNvPr>
+          <p:cNvPr id="45" name="Image 4" descr="preencoded.png">    </p:cNvPr>
           <p:cNvPicPr>
             <a:picLocks noChangeAspect="1"/>
           </p:cNvPicPr>
@@ -20749,8 +21364,8 @@
         </p:blipFill>
         <p:spPr>
           <a:xfrm>
-            <a:off x="6986016" y="5056632"/>
-            <a:ext cx="256032" cy="256032"/>
+            <a:off x="857250" y="5795010"/>
+            <a:ext cx="251460" cy="251460"/>
           </a:xfrm>
           <a:prstGeom prst="rect">
             <a:avLst/>
@@ -20759,14 +21374,14 @@
       </p:pic>
       <p:sp>
         <p:nvSpPr>
-          <p:cNvPr id="31" name="Text 24"/>
-          <p:cNvSpPr txBox="1"/>
-          <p:nvPr/>
-        </p:nvSpPr>
-        <p:spPr>
-          <a:xfrm>
-            <a:off x="7543800" y="4846320"/>
-            <a:ext cx="3931920" cy="685800"/>
+          <p:cNvPr id="46" name="Text 39"/>
+          <p:cNvSpPr txBox="1"/>
+          <p:nvPr/>
+        </p:nvSpPr>
+        <p:spPr>
+          <a:xfrm>
+            <a:off x="1417320" y="5577840"/>
+            <a:ext cx="10042855" cy="685800"/>
           </a:xfrm>
           <a:prstGeom prst="rect">
             <a:avLst/>
@@ -20787,7 +21402,7 @@
                   <a:schemeClr val="tx1"/>
                 </a:solidFill>
               </a:rPr>
-              <a:t>Checked against Irrigation Department gauges and official storage figures</a:t>
+              <a:t>Checked against the daily gauges at the 5 big reservoirs and Kanhindawewa's drone survey</a:t>
             </a:r>
             <a:endParaRPr lang="en-US" sz="1350" dirty="0"/>
           </a:p>

</xml_diff>